<commit_message>
Add chart-analysis pages for revenue targets and debts
Co-Authored-By: Claude Opus 5.5 <noreply@anthropic.com>
Claude-Session: https://claude.ai/code/session_0156m1XJc6TvNjg6SWaGRbjR
</commit_message>
<xml_diff>
--- a/revenue-targets-dashboard/dashboard.pptx
+++ b/revenue-targets-dashboard/dashboard.pptx
@@ -7,9 +7,11 @@
   <p:sldIdLst>
     <p:sldId id="256" r:id="rId2"/>
     <p:sldId id="257" r:id="rId3"/>
+    <p:sldId id="258" r:id="rId4"/>
+    <p:sldId id="259" r:id="rId5"/>
   </p:sldIdLst>
   <p:notesMasterIdLst>
-    <p:notesMasterId r:id="rId4"/>
+    <p:notesMasterId r:id="rId6"/>
   </p:notesMasterIdLst>
   <p:sldSz cx="12192000" cy="6858000"/>
   <p:notesSz cx="6858000" cy="12192000"/>
@@ -108,14 +110,16 @@
   <p:extLst>
     <p:ext uri="{521415D9-36F7-43E2-AB2F-B90AF26B5E84}">
       <p14:sectionLst xmlns:p14="http://schemas.microsoft.com/office/powerpoint/2010/main">
-        <p14:section name="مستهدفات الإيرادات" id="{baa06045-e3e3-719b-111b-cbefb92cc6fd}">
+        <p14:section name="مستهدفات الإيرادات" id="{63f83601-6154-6d35-2510-faf2ee68a1f9}">
           <p14:sldIdLst>
             <p14:sldId id="256"/>
+            <p14:sldId id="257"/>
           </p14:sldIdLst>
         </p14:section>
-        <p14:section name="المديونيات" id="{85134e2e-89ed-ce26-7623-c659c09e8d1c}">
+        <p14:section name="المديونيات" id="{964e87f0-d215-ee33-2b2b-830a1dda47f9}">
           <p14:sldIdLst>
-            <p14:sldId id="257"/>
+            <p14:sldId id="258"/>
+            <p14:sldId id="259"/>
           </p14:sldIdLst>
         </p14:section>
       </p14:sectionLst>
@@ -312,6 +316,1472 @@
         <a:effectLst/>
       </c:spPr>
     </c:plotArea>
+    <c:plotVisOnly val="1"/>
+    <c:dispBlanksAs val="span"/>
+  </c:chart>
+  <c:spPr>
+    <a:noFill/>
+    <a:ln>
+      <a:noFill/>
+    </a:ln>
+    <a:effectLst/>
+  </c:spPr>
+  <c:externalData r:id="rId1">
+    <c:autoUpdate val="0"/>
+  </c:externalData>
+</c:chartSpace>
+</file>
+
+<file path=ppt/charts/chart10.xml><?xml version="1.0" encoding="utf-8"?>
+<c:chartSpace xmlns:c="http://schemas.openxmlformats.org/drawingml/2006/chart" xmlns:a="http://schemas.openxmlformats.org/drawingml/2006/main" xmlns:r="http://schemas.openxmlformats.org/officeDocument/2006/relationships">
+  <c:date1904 val="0"/>
+  <c:roundedCorners val="1"/>
+  <c:chart>
+    <c:autoTitleDeleted val="1"/>
+    <c:plotArea>
+      <c:layout/>
+      <c:barChart>
+        <c:barDir val="bar"/>
+        <c:grouping val="clustered"/>
+        <c:varyColors val="0"/>
+        <c:ser>
+          <c:idx val="0"/>
+          <c:order val="0"/>
+          <c:tx>
+            <c:strRef>
+              <c:f>Sheet1!$B$1</c:f>
+              <c:strCache>
+                <c:ptCount val="1"/>
+                <c:pt idx="0">
+                  <c:v>رصيد المديونية</c:v>
+                </c:pt>
+              </c:strCache>
+            </c:strRef>
+          </c:tx>
+          <c:spPr>
+            <a:solidFill>
+              <a:srgbClr val="2D6A66"/>
+            </a:solidFill>
+            <a:effectLst/>
+          </c:spPr>
+          <c:invertIfNegative val="0"/>
+          <c:dLbls>
+            <c:numFmt formatCode="#,##0" sourceLinked="0"/>
+            <c:txPr>
+              <a:bodyPr/>
+              <a:lstStyle/>
+              <a:p>
+                <a:pPr>
+                  <a:defRPr b="1" i="0" strike="noStrike" sz="1100" u="none">
+                    <a:solidFill>
+                      <a:srgbClr val="1E2B2A"/>
+                    </a:solidFill>
+                    <a:latin typeface="+mn-lt"/>
+                  </a:defRPr>
+                </a:pPr>
+              </a:p>
+            </c:txPr>
+            <c:showLegendKey val="0"/>
+            <c:showVal val="1"/>
+            <c:showCatName val="0"/>
+            <c:showSerName val="0"/>
+            <c:showPercent val="0"/>
+            <c:showBubbleSize val="0"/>
+            <c:showLeaderLines val="0"/>
+          </c:dLbls>
+          <c:cat>
+            <c:multiLvlStrRef>
+              <c:f>Sheet1!$A$2:$A$6</c:f>
+              <c:multiLvlStrCache>
+                <c:ptCount val="5"/>
+                <c:lvl>
+                  <c:pt idx="0">
+                    <c:v>الإيرادات الإستثمارية</c:v>
+                  </c:pt>
+                  <c:pt idx="1">
+                    <c:v>رسوم وتراخيص</c:v>
+                  </c:pt>
+                  <c:pt idx="2">
+                    <c:v>جزاءات وغرامات</c:v>
+                  </c:pt>
+                  <c:pt idx="3">
+                    <c:v>التبغ والإيواء</c:v>
+                  </c:pt>
+                  <c:pt idx="4">
+                    <c:v>أخرى</c:v>
+                  </c:pt>
+                </c:lvl>
+              </c:multiLvlStrCache>
+            </c:multiLvlStrRef>
+          </c:cat>
+          <c:val>
+            <c:numRef>
+              <c:f>Sheet1!$B$2:$B$6</c:f>
+              <c:numCache>
+                <c:formatCode>General</c:formatCode>
+                <c:ptCount val="5"/>
+                <c:pt idx="0">
+                  <c:v>108</c:v>
+                </c:pt>
+                <c:pt idx="1">
+                  <c:v>121</c:v>
+                </c:pt>
+                <c:pt idx="2">
+                  <c:v>124</c:v>
+                </c:pt>
+                <c:pt idx="3">
+                  <c:v>130</c:v>
+                </c:pt>
+                <c:pt idx="4">
+                  <c:v>108</c:v>
+                </c:pt>
+              </c:numCache>
+            </c:numRef>
+          </c:val>
+        </c:ser>
+        <c:ser>
+          <c:idx val="1"/>
+          <c:order val="1"/>
+          <c:tx>
+            <c:strRef>
+              <c:f>Sheet1!$C$1</c:f>
+              <c:strCache>
+                <c:ptCount val="1"/>
+                <c:pt idx="0">
+                  <c:v>ما تم سداده</c:v>
+                </c:pt>
+              </c:strCache>
+            </c:strRef>
+          </c:tx>
+          <c:spPr>
+            <a:solidFill>
+              <a:srgbClr val="86B19A"/>
+            </a:solidFill>
+            <a:effectLst/>
+          </c:spPr>
+          <c:invertIfNegative val="0"/>
+          <c:dLbls>
+            <c:numFmt formatCode="#,##0" sourceLinked="0"/>
+            <c:txPr>
+              <a:bodyPr/>
+              <a:lstStyle/>
+              <a:p>
+                <a:pPr>
+                  <a:defRPr b="1" i="0" strike="noStrike" sz="1100" u="none">
+                    <a:solidFill>
+                      <a:srgbClr val="1E2B2A"/>
+                    </a:solidFill>
+                    <a:latin typeface="+mn-lt"/>
+                  </a:defRPr>
+                </a:pPr>
+              </a:p>
+            </c:txPr>
+            <c:showLegendKey val="0"/>
+            <c:showVal val="1"/>
+            <c:showCatName val="0"/>
+            <c:showSerName val="0"/>
+            <c:showPercent val="0"/>
+            <c:showBubbleSize val="0"/>
+            <c:showLeaderLines val="0"/>
+          </c:dLbls>
+          <c:cat>
+            <c:multiLvlStrRef>
+              <c:f>Sheet1!$A$2:$A$6</c:f>
+              <c:multiLvlStrCache>
+                <c:ptCount val="5"/>
+                <c:lvl>
+                  <c:pt idx="0">
+                    <c:v>الإيرادات الإستثمارية</c:v>
+                  </c:pt>
+                  <c:pt idx="1">
+                    <c:v>رسوم وتراخيص</c:v>
+                  </c:pt>
+                  <c:pt idx="2">
+                    <c:v>جزاءات وغرامات</c:v>
+                  </c:pt>
+                  <c:pt idx="3">
+                    <c:v>التبغ والإيواء</c:v>
+                  </c:pt>
+                  <c:pt idx="4">
+                    <c:v>أخرى</c:v>
+                  </c:pt>
+                </c:lvl>
+              </c:multiLvlStrCache>
+            </c:multiLvlStrRef>
+          </c:cat>
+          <c:val>
+            <c:numRef>
+              <c:f>Sheet1!$C$2:$C$6</c:f>
+              <c:numCache>
+                <c:formatCode>General</c:formatCode>
+                <c:ptCount val="5"/>
+                <c:pt idx="0">
+                  <c:v>277</c:v>
+                </c:pt>
+                <c:pt idx="1">
+                  <c:v>273</c:v>
+                </c:pt>
+                <c:pt idx="2">
+                  <c:v>279</c:v>
+                </c:pt>
+                <c:pt idx="3">
+                  <c:v>283</c:v>
+                </c:pt>
+                <c:pt idx="4">
+                  <c:v>279</c:v>
+                </c:pt>
+              </c:numCache>
+            </c:numRef>
+          </c:val>
+        </c:ser>
+        <c:dLbls>
+          <c:numFmt formatCode="#,##0" sourceLinked="0"/>
+          <c:txPr>
+            <a:bodyPr/>
+            <a:lstStyle/>
+            <a:p>
+              <a:pPr>
+                <a:defRPr b="1" i="0" strike="noStrike" sz="1100" u="none">
+                  <a:solidFill>
+                    <a:srgbClr val="1E2B2A"/>
+                  </a:solidFill>
+                  <a:latin typeface="+mn-lt"/>
+                </a:defRPr>
+              </a:pPr>
+            </a:p>
+          </c:txPr>
+          <c:showLegendKey val="0"/>
+          <c:showVal val="1"/>
+          <c:showCatName val="0"/>
+          <c:showSerName val="0"/>
+          <c:showPercent val="0"/>
+          <c:showBubbleSize val="0"/>
+          <c:showLeaderLines val="0"/>
+        </c:dLbls>
+        <c:gapWidth val="55"/>
+        <c:overlap val="-8"/>
+        <c:axId val="2094734554"/>
+        <c:axId val="2094734552"/>
+        <c:axId val="2094734556"/>
+      </c:barChart>
+      <c:catAx>
+        <c:axId val="2094734554"/>
+        <c:scaling>
+          <c:orientation val="maxMin"/>
+        </c:scaling>
+        <c:delete val="0"/>
+        <c:axPos val="l"/>
+        <c:numFmt formatCode="General" sourceLinked="1"/>
+        <c:majorTickMark val="out"/>
+        <c:minorTickMark val="none"/>
+        <c:tickLblPos val="nextTo"/>
+        <c:spPr>
+          <a:ln w="12700" cap="flat">
+            <a:noFill/>
+            <a:prstDash val="solid"/>
+            <a:round/>
+          </a:ln>
+        </c:spPr>
+        <c:txPr>
+          <a:bodyPr/>
+          <a:lstStyle/>
+          <a:p>
+            <a:pPr>
+              <a:defRPr sz="1100" b="0" i="0" u="none" strike="noStrike">
+                <a:solidFill>
+                  <a:srgbClr val="1E2B2A"/>
+                </a:solidFill>
+                <a:latin typeface="+mn-lt"/>
+              </a:defRPr>
+            </a:pPr>
+            <a:endParaRPr lang="en-US"/>
+          </a:p>
+        </c:txPr>
+        <c:crossAx val="2094734552"/>
+        <c:crosses val="autoZero"/>
+        <c:auto val="1"/>
+        <c:lblAlgn val="ctr"/>
+        <c:noMultiLvlLbl val="1"/>
+      </c:catAx>
+      <c:valAx>
+        <c:axId val="2094734552"/>
+        <c:scaling>
+          <c:orientation val="maxMin"/>
+          <c:max val="400"/>
+          <c:min val="0"/>
+        </c:scaling>
+        <c:delete val="1"/>
+        <c:axPos val="b"/>
+        <c:numFmt formatCode="General" sourceLinked="0"/>
+        <c:majorTickMark val="out"/>
+        <c:minorTickMark val="none"/>
+        <c:tickLblPos val="low"/>
+        <c:spPr>
+          <a:ln w="12700" cap="flat">
+            <a:solidFill>
+              <a:srgbClr val="888888"/>
+            </a:solidFill>
+            <a:prstDash val="solid"/>
+            <a:round/>
+          </a:ln>
+        </c:spPr>
+        <c:txPr>
+          <a:bodyPr/>
+          <a:lstStyle/>
+          <a:p>
+            <a:pPr>
+              <a:defRPr sz="1200" b="0" i="0" u="none" strike="noStrike">
+                <a:solidFill>
+                  <a:srgbClr val="000000"/>
+                </a:solidFill>
+                <a:latin typeface="Arial"/>
+              </a:defRPr>
+            </a:pPr>
+            <a:endParaRPr lang="en-US"/>
+          </a:p>
+        </c:txPr>
+        <c:crossAx val="2094734554"/>
+        <c:crosses val="autoZero"/>
+        <c:crossBetween val="between"/>
+      </c:valAx>
+      <c:spPr>
+        <a:noFill/>
+        <a:ln>
+          <a:noFill/>
+        </a:ln>
+        <a:effectLst/>
+      </c:spPr>
+    </c:plotArea>
+    <c:plotVisOnly val="1"/>
+    <c:dispBlanksAs val="span"/>
+  </c:chart>
+  <c:spPr>
+    <a:noFill/>
+    <a:ln>
+      <a:noFill/>
+    </a:ln>
+    <a:effectLst/>
+  </c:spPr>
+  <c:externalData r:id="rId1">
+    <c:autoUpdate val="0"/>
+  </c:externalData>
+</c:chartSpace>
+</file>
+
+<file path=ppt/charts/chart11.xml><?xml version="1.0" encoding="utf-8"?>
+<c:chartSpace xmlns:c="http://schemas.openxmlformats.org/drawingml/2006/chart" xmlns:a="http://schemas.openxmlformats.org/drawingml/2006/main" xmlns:r="http://schemas.openxmlformats.org/officeDocument/2006/relationships">
+  <c:date1904 val="0"/>
+  <c:roundedCorners val="1"/>
+  <c:chart>
+    <c:autoTitleDeleted val="1"/>
+    <c:plotArea>
+      <c:layout/>
+      <c:barChart>
+        <c:barDir val="col"/>
+        <c:grouping val="clustered"/>
+        <c:varyColors val="0"/>
+        <c:ser>
+          <c:idx val="0"/>
+          <c:order val="0"/>
+          <c:tx>
+            <c:strRef>
+              <c:f>Sheet1!$B$1</c:f>
+              <c:strCache>
+                <c:ptCount val="1"/>
+                <c:pt idx="0">
+                  <c:v>مليون ريال</c:v>
+                </c:pt>
+              </c:strCache>
+            </c:strRef>
+          </c:tx>
+          <c:spPr>
+            <a:solidFill>
+              <a:srgbClr val="2D6A66"/>
+            </a:solidFill>
+            <a:effectLst/>
+          </c:spPr>
+          <c:invertIfNegative val="0"/>
+          <c:dLbls>
+            <c:numFmt formatCode="#,##0" sourceLinked="0"/>
+            <c:txPr>
+              <a:bodyPr/>
+              <a:lstStyle/>
+              <a:p>
+                <a:pPr>
+                  <a:defRPr b="1" i="0" strike="noStrike" sz="1100" u="none">
+                    <a:solidFill>
+                      <a:srgbClr val="1E2B2A"/>
+                    </a:solidFill>
+                    <a:latin typeface="+mn-lt"/>
+                  </a:defRPr>
+                </a:pPr>
+              </a:p>
+            </c:txPr>
+            <c:showLegendKey val="0"/>
+            <c:showVal val="1"/>
+            <c:showCatName val="0"/>
+            <c:showSerName val="0"/>
+            <c:showPercent val="0"/>
+            <c:showBubbleSize val="0"/>
+            <c:showLeaderLines val="0"/>
+          </c:dLbls>
+          <c:cat>
+            <c:multiLvlStrRef>
+              <c:f>Sheet1!$A$2:$A$5</c:f>
+              <c:multiLvlStrCache>
+                <c:ptCount val="4"/>
+                <c:lvl>
+                  <c:pt idx="0">
+                    <c:v>رصيد بداية السنة</c:v>
+                  </c:pt>
+                  <c:pt idx="1">
+                    <c:v>الملغي</c:v>
+                  </c:pt>
+                  <c:pt idx="2">
+                    <c:v>ما تم سداده</c:v>
+                  </c:pt>
+                  <c:pt idx="3">
+                    <c:v>المتبقي</c:v>
+                  </c:pt>
+                </c:lvl>
+              </c:multiLvlStrCache>
+            </c:multiLvlStrRef>
+          </c:cat>
+          <c:val>
+            <c:numRef>
+              <c:f>Sheet1!$B$2:$B$5</c:f>
+              <c:numCache>
+                <c:formatCode>General</c:formatCode>
+                <c:ptCount val="4"/>
+                <c:pt idx="0">
+                  <c:v>121</c:v>
+                </c:pt>
+                <c:pt idx="1">
+                  <c:v>119</c:v>
+                </c:pt>
+                <c:pt idx="2">
+                  <c:v>328</c:v>
+                </c:pt>
+                <c:pt idx="3">
+                  <c:v>125</c:v>
+                </c:pt>
+              </c:numCache>
+            </c:numRef>
+          </c:val>
+        </c:ser>
+        <c:dLbls>
+          <c:numFmt formatCode="#,##0" sourceLinked="0"/>
+          <c:txPr>
+            <a:bodyPr/>
+            <a:lstStyle/>
+            <a:p>
+              <a:pPr>
+                <a:defRPr b="1" i="0" strike="noStrike" sz="1100" u="none">
+                  <a:solidFill>
+                    <a:srgbClr val="1E2B2A"/>
+                  </a:solidFill>
+                  <a:latin typeface="+mn-lt"/>
+                </a:defRPr>
+              </a:pPr>
+            </a:p>
+          </c:txPr>
+          <c:showLegendKey val="0"/>
+          <c:showVal val="1"/>
+          <c:showCatName val="0"/>
+          <c:showSerName val="0"/>
+          <c:showPercent val="0"/>
+          <c:showBubbleSize val="0"/>
+          <c:showLeaderLines val="0"/>
+        </c:dLbls>
+        <c:gapWidth val="80"/>
+        <c:overlap val="-10"/>
+        <c:axId val="2094734554"/>
+        <c:axId val="2094734552"/>
+        <c:axId val="2094734556"/>
+      </c:barChart>
+      <c:catAx>
+        <c:axId val="2094734554"/>
+        <c:scaling>
+          <c:orientation val="maxMin"/>
+        </c:scaling>
+        <c:delete val="0"/>
+        <c:axPos val="b"/>
+        <c:numFmt formatCode="General" sourceLinked="1"/>
+        <c:majorTickMark val="out"/>
+        <c:minorTickMark val="none"/>
+        <c:tickLblPos val="low"/>
+        <c:spPr>
+          <a:ln w="12700" cap="flat">
+            <a:solidFill>
+              <a:srgbClr val="888888"/>
+            </a:solidFill>
+            <a:prstDash val="solid"/>
+            <a:round/>
+          </a:ln>
+        </c:spPr>
+        <c:txPr>
+          <a:bodyPr/>
+          <a:lstStyle/>
+          <a:p>
+            <a:pPr>
+              <a:defRPr sz="1100" b="0" i="0" u="none" strike="noStrike">
+                <a:solidFill>
+                  <a:srgbClr val="1E2B2A"/>
+                </a:solidFill>
+                <a:latin typeface="+mn-lt"/>
+              </a:defRPr>
+            </a:pPr>
+            <a:endParaRPr lang="en-US"/>
+          </a:p>
+        </c:txPr>
+        <c:crossAx val="2094734552"/>
+        <c:crosses val="autoZero"/>
+        <c:auto val="1"/>
+        <c:lblAlgn val="ctr"/>
+        <c:noMultiLvlLbl val="1"/>
+      </c:catAx>
+      <c:valAx>
+        <c:axId val="2094734552"/>
+        <c:scaling>
+          <c:orientation val="minMax"/>
+          <c:max val="380"/>
+          <c:min val="0"/>
+        </c:scaling>
+        <c:delete val="1"/>
+        <c:axPos val="l"/>
+        <c:numFmt formatCode="General" sourceLinked="0"/>
+        <c:majorTickMark val="out"/>
+        <c:minorTickMark val="none"/>
+        <c:tickLblPos val="nextTo"/>
+        <c:spPr>
+          <a:ln w="12700" cap="flat">
+            <a:solidFill>
+              <a:srgbClr val="888888"/>
+            </a:solidFill>
+            <a:prstDash val="solid"/>
+            <a:round/>
+          </a:ln>
+        </c:spPr>
+        <c:txPr>
+          <a:bodyPr/>
+          <a:lstStyle/>
+          <a:p>
+            <a:pPr>
+              <a:defRPr sz="1200" b="0" i="0" u="none" strike="noStrike">
+                <a:solidFill>
+                  <a:srgbClr val="000000"/>
+                </a:solidFill>
+                <a:latin typeface="Arial"/>
+              </a:defRPr>
+            </a:pPr>
+            <a:endParaRPr lang="en-US"/>
+          </a:p>
+        </c:txPr>
+        <c:crossAx val="2094734554"/>
+        <c:crosses val="autoZero"/>
+        <c:crossBetween val="between"/>
+      </c:valAx>
+      <c:spPr>
+        <a:noFill/>
+        <a:ln>
+          <a:noFill/>
+        </a:ln>
+        <a:effectLst/>
+      </c:spPr>
+    </c:plotArea>
+    <c:plotVisOnly val="1"/>
+    <c:dispBlanksAs val="span"/>
+  </c:chart>
+  <c:spPr>
+    <a:noFill/>
+    <a:ln>
+      <a:noFill/>
+    </a:ln>
+    <a:effectLst/>
+  </c:spPr>
+  <c:externalData r:id="rId1">
+    <c:autoUpdate val="0"/>
+  </c:externalData>
+</c:chartSpace>
+</file>
+
+<file path=ppt/charts/chart12.xml><?xml version="1.0" encoding="utf-8"?>
+<c:chartSpace xmlns:c="http://schemas.openxmlformats.org/drawingml/2006/chart" xmlns:a="http://schemas.openxmlformats.org/drawingml/2006/main" xmlns:r="http://schemas.openxmlformats.org/officeDocument/2006/relationships">
+  <c:date1904 val="0"/>
+  <c:roundedCorners val="1"/>
+  <c:chart>
+    <c:autoTitleDeleted val="1"/>
+    <c:plotArea>
+      <c:layout/>
+      <c:doughnutChart>
+        <c:varyColors val="1"/>
+        <c:ser>
+          <c:idx val="0"/>
+          <c:order val="0"/>
+          <c:tx>
+            <c:strRef>
+              <c:f>Sheet1!$B$1</c:f>
+              <c:strCache>
+                <c:ptCount val="1"/>
+                <c:pt idx="0">
+                  <c:v>نسبة</c:v>
+                </c:pt>
+              </c:strCache>
+            </c:strRef>
+          </c:tx>
+          <c:spPr>
+            <a:solidFill>
+              <a:schemeClr val="accent1"/>
+            </a:solidFill>
+            <a:ln w="9525" cap="flat">
+              <a:solidFill>
+                <a:srgbClr val="F9F9F9"/>
+              </a:solidFill>
+              <a:prstDash val="solid"/>
+              <a:round/>
+            </a:ln>
+            <a:effectLst/>
+          </c:spPr>
+          <c:dPt>
+            <c:idx val="0"/>
+            <c:bubble3D val="0"/>
+            <c:spPr>
+              <a:solidFill>
+                <a:srgbClr val="2D6A66"/>
+              </a:solidFill>
+              <a:ln w="6350" cap="flat">
+                <a:solidFill>
+                  <a:srgbClr val="FFFFFF"/>
+                </a:solidFill>
+                <a:prstDash val="solid"/>
+                <a:round/>
+              </a:ln>
+              <a:effectLst/>
+            </c:spPr>
+          </c:dPt>
+          <c:dPt>
+            <c:idx val="1"/>
+            <c:bubble3D val="0"/>
+            <c:spPr>
+              <a:solidFill>
+                <a:srgbClr val="E4E9E8"/>
+              </a:solidFill>
+              <a:ln w="6350" cap="flat">
+                <a:solidFill>
+                  <a:srgbClr val="FFFFFF"/>
+                </a:solidFill>
+                <a:prstDash val="solid"/>
+                <a:round/>
+              </a:ln>
+              <a:effectLst/>
+            </c:spPr>
+          </c:dPt>
+          <c:dLbls>
+            <c:dLbl>
+              <c:idx val="0"/>
+              <c:numFmt formatCode="General" sourceLinked="0"/>
+              <c:spPr/>
+              <c:txPr>
+                <a:bodyPr/>
+                <a:lstStyle/>
+                <a:p>
+                  <a:pPr>
+                    <a:defRPr sz="1200" b="0" i="0" u="none" strike="noStrike">
+                      <a:solidFill>
+                        <a:srgbClr val="000000"/>
+                      </a:solidFill>
+                      <a:latin typeface="Arial"/>
+                    </a:defRPr>
+                  </a:pPr>
+                </a:p>
+              </c:txPr>
+              <c:showLegendKey val="0"/>
+              <c:showVal val="0"/>
+              <c:showCatName val="0"/>
+              <c:showSerName val="0"/>
+              <c:showPercent val="0"/>
+              <c:showBubbleSize val="0"/>
+            </c:dLbl>
+            <c:dLbl>
+              <c:idx val="1"/>
+              <c:numFmt formatCode="General" sourceLinked="0"/>
+              <c:spPr/>
+              <c:txPr>
+                <a:bodyPr/>
+                <a:lstStyle/>
+                <a:p>
+                  <a:pPr>
+                    <a:defRPr sz="1200" b="0" i="0" u="none" strike="noStrike">
+                      <a:solidFill>
+                        <a:srgbClr val="000000"/>
+                      </a:solidFill>
+                      <a:latin typeface="Arial"/>
+                    </a:defRPr>
+                  </a:pPr>
+                </a:p>
+              </c:txPr>
+              <c:showLegendKey val="0"/>
+              <c:showVal val="0"/>
+              <c:showCatName val="0"/>
+              <c:showSerName val="0"/>
+              <c:showPercent val="0"/>
+              <c:showBubbleSize val="0"/>
+            </c:dLbl>
+            <c:numFmt formatCode="General" sourceLinked="0"/>
+            <c:txPr>
+              <a:bodyPr/>
+              <a:lstStyle/>
+              <a:p>
+                <a:pPr>
+                  <a:defRPr sz="1800" b="0" i="0" u="none" strike="noStrike">
+                    <a:solidFill>
+                      <a:srgbClr val="000000"/>
+                    </a:solidFill>
+                    <a:latin typeface="Arial"/>
+                  </a:defRPr>
+                </a:pPr>
+              </a:p>
+            </c:txPr>
+            <c:showLegendKey val="0"/>
+            <c:showVal val="0"/>
+            <c:showCatName val="1"/>
+            <c:showSerName val="0"/>
+            <c:showPercent val="1"/>
+            <c:showBubbleSize val="0"/>
+            <c:showLeaderLines val="0"/>
+          </c:dLbls>
+          <c:cat>
+            <c:strRef>
+              <c:f>Sheet1!$A$2:$A$3</c:f>
+              <c:strCache>
+                <c:ptCount val="2"/>
+                <c:pt idx="0">
+                  <c:v>المنجز</c:v>
+                </c:pt>
+                <c:pt idx="1">
+                  <c:v>المتبقي</c:v>
+                </c:pt>
+              </c:strCache>
+            </c:strRef>
+          </c:cat>
+          <c:val>
+            <c:numRef>
+              <c:f>Sheet1!$B$2:$B$3</c:f>
+              <c:numCache>
+                <c:ptCount val="2"/>
+                <c:pt idx="0">
+                  <c:v>62</c:v>
+                </c:pt>
+                <c:pt idx="1">
+                  <c:v>38</c:v>
+                </c:pt>
+              </c:numCache>
+            </c:numRef>
+          </c:val>
+        </c:ser>
+        <c:firstSliceAng val="0"/>
+        <c:holeSize val="74"/>
+      </c:doughnutChart>
+      <c:spPr>
+        <a:noFill/>
+        <a:ln>
+          <a:noFill/>
+        </a:ln>
+        <a:effectLst/>
+      </c:spPr>
+    </c:plotArea>
+    <c:plotVisOnly val="1"/>
+    <c:dispBlanksAs val="span"/>
+  </c:chart>
+  <c:spPr>
+    <a:noFill/>
+    <a:ln>
+      <a:noFill/>
+    </a:ln>
+    <a:effectLst/>
+  </c:spPr>
+  <c:externalData r:id="rId1">
+    <c:autoUpdate val="0"/>
+  </c:externalData>
+</c:chartSpace>
+</file>
+
+<file path=ppt/charts/chart13.xml><?xml version="1.0" encoding="utf-8"?>
+<c:chartSpace xmlns:c="http://schemas.openxmlformats.org/drawingml/2006/chart" xmlns:a="http://schemas.openxmlformats.org/drawingml/2006/main" xmlns:r="http://schemas.openxmlformats.org/officeDocument/2006/relationships">
+  <c:date1904 val="0"/>
+  <c:roundedCorners val="1"/>
+  <c:chart>
+    <c:autoTitleDeleted val="1"/>
+    <c:plotArea>
+      <c:layout/>
+      <c:barChart>
+        <c:barDir val="col"/>
+        <c:grouping val="clustered"/>
+        <c:varyColors val="0"/>
+        <c:ser>
+          <c:idx val="0"/>
+          <c:order val="0"/>
+          <c:tx>
+            <c:strRef>
+              <c:f>Sheet1!$B$1</c:f>
+              <c:strCache>
+                <c:ptCount val="1"/>
+                <c:pt idx="0">
+                  <c:v>2007 - 2016</c:v>
+                </c:pt>
+              </c:strCache>
+            </c:strRef>
+          </c:tx>
+          <c:spPr>
+            <a:solidFill>
+              <a:srgbClr val="2D6A66"/>
+            </a:solidFill>
+            <a:effectLst/>
+          </c:spPr>
+          <c:invertIfNegative val="0"/>
+          <c:dLbls>
+            <c:numFmt formatCode="#,##0" sourceLinked="0"/>
+            <c:txPr>
+              <a:bodyPr/>
+              <a:lstStyle/>
+              <a:p>
+                <a:pPr>
+                  <a:defRPr b="1" i="0" strike="noStrike" sz="1100" u="none">
+                    <a:solidFill>
+                      <a:srgbClr val="1E2B2A"/>
+                    </a:solidFill>
+                    <a:latin typeface="+mn-lt"/>
+                  </a:defRPr>
+                </a:pPr>
+              </a:p>
+            </c:txPr>
+            <c:showLegendKey val="0"/>
+            <c:showVal val="1"/>
+            <c:showCatName val="0"/>
+            <c:showSerName val="0"/>
+            <c:showPercent val="0"/>
+            <c:showBubbleSize val="0"/>
+            <c:showLeaderLines val="0"/>
+          </c:dLbls>
+          <c:cat>
+            <c:multiLvlStrRef>
+              <c:f>Sheet1!$A$2:$A$4</c:f>
+              <c:multiLvlStrCache>
+                <c:ptCount val="3"/>
+                <c:lvl>
+                  <c:pt idx="0">
+                    <c:v>إجمالي رصيد المديونية</c:v>
+                  </c:pt>
+                  <c:pt idx="1">
+                    <c:v>إجمالي ما تم سداده</c:v>
+                  </c:pt>
+                  <c:pt idx="2">
+                    <c:v>إجمالي المتبقي</c:v>
+                  </c:pt>
+                </c:lvl>
+              </c:multiLvlStrCache>
+            </c:multiLvlStrRef>
+          </c:cat>
+          <c:val>
+            <c:numRef>
+              <c:f>Sheet1!$B$2:$B$4</c:f>
+              <c:numCache>
+                <c:formatCode>General</c:formatCode>
+                <c:ptCount val="3"/>
+                <c:pt idx="0">
+                  <c:v>116</c:v>
+                </c:pt>
+                <c:pt idx="1">
+                  <c:v>299</c:v>
+                </c:pt>
+                <c:pt idx="2">
+                  <c:v>122</c:v>
+                </c:pt>
+              </c:numCache>
+            </c:numRef>
+          </c:val>
+        </c:ser>
+        <c:ser>
+          <c:idx val="1"/>
+          <c:order val="1"/>
+          <c:tx>
+            <c:strRef>
+              <c:f>Sheet1!$C$1</c:f>
+              <c:strCache>
+                <c:ptCount val="1"/>
+                <c:pt idx="0">
+                  <c:v>2017 - 2025</c:v>
+                </c:pt>
+              </c:strCache>
+            </c:strRef>
+          </c:tx>
+          <c:spPr>
+            <a:solidFill>
+              <a:srgbClr val="86B19A"/>
+            </a:solidFill>
+            <a:effectLst/>
+          </c:spPr>
+          <c:invertIfNegative val="0"/>
+          <c:dLbls>
+            <c:numFmt formatCode="#,##0" sourceLinked="0"/>
+            <c:txPr>
+              <a:bodyPr/>
+              <a:lstStyle/>
+              <a:p>
+                <a:pPr>
+                  <a:defRPr b="1" i="0" strike="noStrike" sz="1100" u="none">
+                    <a:solidFill>
+                      <a:srgbClr val="1E2B2A"/>
+                    </a:solidFill>
+                    <a:latin typeface="+mn-lt"/>
+                  </a:defRPr>
+                </a:pPr>
+              </a:p>
+            </c:txPr>
+            <c:showLegendKey val="0"/>
+            <c:showVal val="1"/>
+            <c:showCatName val="0"/>
+            <c:showSerName val="0"/>
+            <c:showPercent val="0"/>
+            <c:showBubbleSize val="0"/>
+            <c:showLeaderLines val="0"/>
+          </c:dLbls>
+          <c:cat>
+            <c:multiLvlStrRef>
+              <c:f>Sheet1!$A$2:$A$4</c:f>
+              <c:multiLvlStrCache>
+                <c:ptCount val="3"/>
+                <c:lvl>
+                  <c:pt idx="0">
+                    <c:v>إجمالي رصيد المديونية</c:v>
+                  </c:pt>
+                  <c:pt idx="1">
+                    <c:v>إجمالي ما تم سداده</c:v>
+                  </c:pt>
+                  <c:pt idx="2">
+                    <c:v>إجمالي المتبقي</c:v>
+                  </c:pt>
+                </c:lvl>
+              </c:multiLvlStrCache>
+            </c:multiLvlStrRef>
+          </c:cat>
+          <c:val>
+            <c:numRef>
+              <c:f>Sheet1!$C$2:$C$4</c:f>
+              <c:numCache>
+                <c:formatCode>General</c:formatCode>
+                <c:ptCount val="3"/>
+                <c:pt idx="0">
+                  <c:v>126</c:v>
+                </c:pt>
+                <c:pt idx="1">
+                  <c:v>327</c:v>
+                </c:pt>
+                <c:pt idx="2">
+                  <c:v>112</c:v>
+                </c:pt>
+              </c:numCache>
+            </c:numRef>
+          </c:val>
+        </c:ser>
+        <c:dLbls>
+          <c:numFmt formatCode="#,##0" sourceLinked="0"/>
+          <c:txPr>
+            <a:bodyPr/>
+            <a:lstStyle/>
+            <a:p>
+              <a:pPr>
+                <a:defRPr b="1" i="0" strike="noStrike" sz="1100" u="none">
+                  <a:solidFill>
+                    <a:srgbClr val="1E2B2A"/>
+                  </a:solidFill>
+                  <a:latin typeface="+mn-lt"/>
+                </a:defRPr>
+              </a:pPr>
+            </a:p>
+          </c:txPr>
+          <c:showLegendKey val="0"/>
+          <c:showVal val="1"/>
+          <c:showCatName val="0"/>
+          <c:showSerName val="0"/>
+          <c:showPercent val="0"/>
+          <c:showBubbleSize val="0"/>
+          <c:showLeaderLines val="0"/>
+        </c:dLbls>
+        <c:gapWidth val="70"/>
+        <c:overlap val="-10"/>
+        <c:axId val="2094734554"/>
+        <c:axId val="2094734552"/>
+        <c:axId val="2094734556"/>
+      </c:barChart>
+      <c:catAx>
+        <c:axId val="2094734554"/>
+        <c:scaling>
+          <c:orientation val="maxMin"/>
+        </c:scaling>
+        <c:delete val="0"/>
+        <c:axPos val="b"/>
+        <c:numFmt formatCode="General" sourceLinked="1"/>
+        <c:majorTickMark val="out"/>
+        <c:minorTickMark val="none"/>
+        <c:tickLblPos val="low"/>
+        <c:spPr>
+          <a:ln w="12700" cap="flat">
+            <a:solidFill>
+              <a:srgbClr val="888888"/>
+            </a:solidFill>
+            <a:prstDash val="solid"/>
+            <a:round/>
+          </a:ln>
+        </c:spPr>
+        <c:txPr>
+          <a:bodyPr/>
+          <a:lstStyle/>
+          <a:p>
+            <a:pPr>
+              <a:defRPr sz="1100" b="0" i="0" u="none" strike="noStrike">
+                <a:solidFill>
+                  <a:srgbClr val="1E2B2A"/>
+                </a:solidFill>
+                <a:latin typeface="+mn-lt"/>
+              </a:defRPr>
+            </a:pPr>
+            <a:endParaRPr lang="en-US"/>
+          </a:p>
+        </c:txPr>
+        <c:crossAx val="2094734552"/>
+        <c:crosses val="autoZero"/>
+        <c:auto val="1"/>
+        <c:lblAlgn val="ctr"/>
+        <c:noMultiLvlLbl val="1"/>
+      </c:catAx>
+      <c:valAx>
+        <c:axId val="2094734552"/>
+        <c:scaling>
+          <c:orientation val="minMax"/>
+          <c:max val="380"/>
+          <c:min val="0"/>
+        </c:scaling>
+        <c:delete val="1"/>
+        <c:axPos val="l"/>
+        <c:numFmt formatCode="General" sourceLinked="0"/>
+        <c:majorTickMark val="out"/>
+        <c:minorTickMark val="none"/>
+        <c:tickLblPos val="nextTo"/>
+        <c:spPr>
+          <a:ln w="12700" cap="flat">
+            <a:solidFill>
+              <a:srgbClr val="888888"/>
+            </a:solidFill>
+            <a:prstDash val="solid"/>
+            <a:round/>
+          </a:ln>
+        </c:spPr>
+        <c:txPr>
+          <a:bodyPr/>
+          <a:lstStyle/>
+          <a:p>
+            <a:pPr>
+              <a:defRPr sz="1200" b="0" i="0" u="none" strike="noStrike">
+                <a:solidFill>
+                  <a:srgbClr val="000000"/>
+                </a:solidFill>
+                <a:latin typeface="Arial"/>
+              </a:defRPr>
+            </a:pPr>
+            <a:endParaRPr lang="en-US"/>
+          </a:p>
+        </c:txPr>
+        <c:crossAx val="2094734554"/>
+        <c:crosses val="autoZero"/>
+        <c:crossBetween val="between"/>
+      </c:valAx>
+      <c:spPr>
+        <a:noFill/>
+        <a:ln>
+          <a:noFill/>
+        </a:ln>
+        <a:effectLst/>
+      </c:spPr>
+    </c:plotArea>
+    <c:legend>
+      <c:legendPos val="t"/>
+      <c:overlay val="0"/>
+      <c:txPr>
+        <a:bodyPr/>
+        <a:lstStyle/>
+        <a:p>
+          <a:pPr>
+            <a:defRPr sz="1100">
+              <a:solidFill>
+                <a:srgbClr val="6B7675"/>
+              </a:solidFill>
+              <a:latin typeface="+mn-lt"/>
+              <a:cs typeface="+mn-lt"/>
+            </a:defRPr>
+          </a:pPr>
+          <a:endParaRPr lang="en-US"/>
+        </a:p>
+      </c:txPr>
+    </c:legend>
+    <c:plotVisOnly val="1"/>
+    <c:dispBlanksAs val="span"/>
+  </c:chart>
+  <c:spPr>
+    <a:noFill/>
+    <a:ln>
+      <a:noFill/>
+    </a:ln>
+    <a:effectLst/>
+  </c:spPr>
+  <c:externalData r:id="rId1">
+    <c:autoUpdate val="0"/>
+  </c:externalData>
+</c:chartSpace>
+</file>
+
+<file path=ppt/charts/chart14.xml><?xml version="1.0" encoding="utf-8"?>
+<c:chartSpace xmlns:c="http://schemas.openxmlformats.org/drawingml/2006/chart" xmlns:a="http://schemas.openxmlformats.org/drawingml/2006/main" xmlns:r="http://schemas.openxmlformats.org/officeDocument/2006/relationships">
+  <c:date1904 val="0"/>
+  <c:roundedCorners val="1"/>
+  <c:chart>
+    <c:autoTitleDeleted val="1"/>
+    <c:plotArea>
+      <c:layout/>
+      <c:barChart>
+        <c:barDir val="col"/>
+        <c:grouping val="clustered"/>
+        <c:varyColors val="0"/>
+        <c:ser>
+          <c:idx val="0"/>
+          <c:order val="0"/>
+          <c:tx>
+            <c:strRef>
+              <c:f>Sheet1!$B$1</c:f>
+              <c:strCache>
+                <c:ptCount val="1"/>
+                <c:pt idx="0">
+                  <c:v>2007 - 2016</c:v>
+                </c:pt>
+              </c:strCache>
+            </c:strRef>
+          </c:tx>
+          <c:spPr>
+            <a:solidFill>
+              <a:srgbClr val="2D6A66"/>
+            </a:solidFill>
+            <a:effectLst/>
+          </c:spPr>
+          <c:invertIfNegative val="0"/>
+          <c:dLbls>
+            <c:numFmt formatCode="#,##0" sourceLinked="0"/>
+            <c:txPr>
+              <a:bodyPr/>
+              <a:lstStyle/>
+              <a:p>
+                <a:pPr>
+                  <a:defRPr b="1" i="0" strike="noStrike" sz="1100" u="none">
+                    <a:solidFill>
+                      <a:srgbClr val="1E2B2A"/>
+                    </a:solidFill>
+                    <a:latin typeface="+mn-lt"/>
+                  </a:defRPr>
+                </a:pPr>
+              </a:p>
+            </c:txPr>
+            <c:showLegendKey val="0"/>
+            <c:showVal val="1"/>
+            <c:showCatName val="0"/>
+            <c:showSerName val="0"/>
+            <c:showPercent val="0"/>
+            <c:showBubbleSize val="0"/>
+            <c:showLeaderLines val="0"/>
+          </c:dLbls>
+          <c:cat>
+            <c:multiLvlStrRef>
+              <c:f>Sheet1!$A$2:$A$6</c:f>
+              <c:multiLvlStrCache>
+                <c:ptCount val="5"/>
+                <c:lvl>
+                  <c:pt idx="0">
+                    <c:v>الإيرادات الإستثمارية</c:v>
+                  </c:pt>
+                  <c:pt idx="1">
+                    <c:v>رسوم وتراخيص</c:v>
+                  </c:pt>
+                  <c:pt idx="2">
+                    <c:v>جزاءات وغرامات</c:v>
+                  </c:pt>
+                  <c:pt idx="3">
+                    <c:v>التبغ والإيواء</c:v>
+                  </c:pt>
+                  <c:pt idx="4">
+                    <c:v>أخرى</c:v>
+                  </c:pt>
+                </c:lvl>
+              </c:multiLvlStrCache>
+            </c:multiLvlStrRef>
+          </c:cat>
+          <c:val>
+            <c:numRef>
+              <c:f>Sheet1!$B$2:$B$6</c:f>
+              <c:numCache>
+                <c:formatCode>General</c:formatCode>
+                <c:ptCount val="5"/>
+                <c:pt idx="0">
+                  <c:v>116</c:v>
+                </c:pt>
+                <c:pt idx="1">
+                  <c:v>116</c:v>
+                </c:pt>
+                <c:pt idx="2">
+                  <c:v>128</c:v>
+                </c:pt>
+                <c:pt idx="3">
+                  <c:v>110</c:v>
+                </c:pt>
+                <c:pt idx="4">
+                  <c:v>117</c:v>
+                </c:pt>
+              </c:numCache>
+            </c:numRef>
+          </c:val>
+        </c:ser>
+        <c:ser>
+          <c:idx val="1"/>
+          <c:order val="1"/>
+          <c:tx>
+            <c:strRef>
+              <c:f>Sheet1!$C$1</c:f>
+              <c:strCache>
+                <c:ptCount val="1"/>
+                <c:pt idx="0">
+                  <c:v>2017 - 2025</c:v>
+                </c:pt>
+              </c:strCache>
+            </c:strRef>
+          </c:tx>
+          <c:spPr>
+            <a:solidFill>
+              <a:srgbClr val="86B19A"/>
+            </a:solidFill>
+            <a:effectLst/>
+          </c:spPr>
+          <c:invertIfNegative val="0"/>
+          <c:dLbls>
+            <c:numFmt formatCode="#,##0" sourceLinked="0"/>
+            <c:txPr>
+              <a:bodyPr/>
+              <a:lstStyle/>
+              <a:p>
+                <a:pPr>
+                  <a:defRPr b="1" i="0" strike="noStrike" sz="1100" u="none">
+                    <a:solidFill>
+                      <a:srgbClr val="1E2B2A"/>
+                    </a:solidFill>
+                    <a:latin typeface="+mn-lt"/>
+                  </a:defRPr>
+                </a:pPr>
+              </a:p>
+            </c:txPr>
+            <c:showLegendKey val="0"/>
+            <c:showVal val="1"/>
+            <c:showCatName val="0"/>
+            <c:showSerName val="0"/>
+            <c:showPercent val="0"/>
+            <c:showBubbleSize val="0"/>
+            <c:showLeaderLines val="0"/>
+          </c:dLbls>
+          <c:cat>
+            <c:multiLvlStrRef>
+              <c:f>Sheet1!$A$2:$A$6</c:f>
+              <c:multiLvlStrCache>
+                <c:ptCount val="5"/>
+                <c:lvl>
+                  <c:pt idx="0">
+                    <c:v>الإيرادات الإستثمارية</c:v>
+                  </c:pt>
+                  <c:pt idx="1">
+                    <c:v>رسوم وتراخيص</c:v>
+                  </c:pt>
+                  <c:pt idx="2">
+                    <c:v>جزاءات وغرامات</c:v>
+                  </c:pt>
+                  <c:pt idx="3">
+                    <c:v>التبغ والإيواء</c:v>
+                  </c:pt>
+                  <c:pt idx="4">
+                    <c:v>أخرى</c:v>
+                  </c:pt>
+                </c:lvl>
+              </c:multiLvlStrCache>
+            </c:multiLvlStrRef>
+          </c:cat>
+          <c:val>
+            <c:numRef>
+              <c:f>Sheet1!$C$2:$C$6</c:f>
+              <c:numCache>
+                <c:formatCode>General</c:formatCode>
+                <c:ptCount val="5"/>
+                <c:pt idx="0">
+                  <c:v>108</c:v>
+                </c:pt>
+                <c:pt idx="1">
+                  <c:v>121</c:v>
+                </c:pt>
+                <c:pt idx="2">
+                  <c:v>124</c:v>
+                </c:pt>
+                <c:pt idx="3">
+                  <c:v>130</c:v>
+                </c:pt>
+                <c:pt idx="4">
+                  <c:v>108</c:v>
+                </c:pt>
+              </c:numCache>
+            </c:numRef>
+          </c:val>
+        </c:ser>
+        <c:dLbls>
+          <c:numFmt formatCode="#,##0" sourceLinked="0"/>
+          <c:txPr>
+            <a:bodyPr/>
+            <a:lstStyle/>
+            <a:p>
+              <a:pPr>
+                <a:defRPr b="1" i="0" strike="noStrike" sz="1100" u="none">
+                  <a:solidFill>
+                    <a:srgbClr val="1E2B2A"/>
+                  </a:solidFill>
+                  <a:latin typeface="+mn-lt"/>
+                </a:defRPr>
+              </a:pPr>
+            </a:p>
+          </c:txPr>
+          <c:showLegendKey val="0"/>
+          <c:showVal val="1"/>
+          <c:showCatName val="0"/>
+          <c:showSerName val="0"/>
+          <c:showPercent val="0"/>
+          <c:showBubbleSize val="0"/>
+          <c:showLeaderLines val="0"/>
+        </c:dLbls>
+        <c:gapWidth val="60"/>
+        <c:overlap val="-5"/>
+        <c:axId val="2094734554"/>
+        <c:axId val="2094734552"/>
+        <c:axId val="2094734556"/>
+      </c:barChart>
+      <c:catAx>
+        <c:axId val="2094734554"/>
+        <c:scaling>
+          <c:orientation val="maxMin"/>
+        </c:scaling>
+        <c:delete val="0"/>
+        <c:axPos val="b"/>
+        <c:numFmt formatCode="General" sourceLinked="1"/>
+        <c:majorTickMark val="out"/>
+        <c:minorTickMark val="none"/>
+        <c:tickLblPos val="low"/>
+        <c:spPr>
+          <a:ln w="12700" cap="flat">
+            <a:solidFill>
+              <a:srgbClr val="888888"/>
+            </a:solidFill>
+            <a:prstDash val="solid"/>
+            <a:round/>
+          </a:ln>
+        </c:spPr>
+        <c:txPr>
+          <a:bodyPr/>
+          <a:lstStyle/>
+          <a:p>
+            <a:pPr>
+              <a:defRPr sz="1100" b="0" i="0" u="none" strike="noStrike">
+                <a:solidFill>
+                  <a:srgbClr val="1E2B2A"/>
+                </a:solidFill>
+                <a:latin typeface="+mn-lt"/>
+              </a:defRPr>
+            </a:pPr>
+            <a:endParaRPr lang="en-US"/>
+          </a:p>
+        </c:txPr>
+        <c:crossAx val="2094734552"/>
+        <c:crosses val="autoZero"/>
+        <c:auto val="1"/>
+        <c:lblAlgn val="ctr"/>
+        <c:noMultiLvlLbl val="1"/>
+      </c:catAx>
+      <c:valAx>
+        <c:axId val="2094734552"/>
+        <c:scaling>
+          <c:orientation val="minMax"/>
+          <c:max val="150"/>
+          <c:min val="0"/>
+        </c:scaling>
+        <c:delete val="1"/>
+        <c:axPos val="l"/>
+        <c:numFmt formatCode="General" sourceLinked="0"/>
+        <c:majorTickMark val="out"/>
+        <c:minorTickMark val="none"/>
+        <c:tickLblPos val="nextTo"/>
+        <c:spPr>
+          <a:ln w="12700" cap="flat">
+            <a:solidFill>
+              <a:srgbClr val="888888"/>
+            </a:solidFill>
+            <a:prstDash val="solid"/>
+            <a:round/>
+          </a:ln>
+        </c:spPr>
+        <c:txPr>
+          <a:bodyPr/>
+          <a:lstStyle/>
+          <a:p>
+            <a:pPr>
+              <a:defRPr sz="1200" b="0" i="0" u="none" strike="noStrike">
+                <a:solidFill>
+                  <a:srgbClr val="000000"/>
+                </a:solidFill>
+                <a:latin typeface="Arial"/>
+              </a:defRPr>
+            </a:pPr>
+            <a:endParaRPr lang="en-US"/>
+          </a:p>
+        </c:txPr>
+        <c:crossAx val="2094734554"/>
+        <c:crosses val="autoZero"/>
+        <c:crossBetween val="between"/>
+      </c:valAx>
+      <c:spPr>
+        <a:noFill/>
+        <a:ln>
+          <a:noFill/>
+        </a:ln>
+        <a:effectLst/>
+      </c:spPr>
+    </c:plotArea>
+    <c:legend>
+      <c:legendPos val="t"/>
+      <c:overlay val="0"/>
+      <c:txPr>
+        <a:bodyPr/>
+        <a:lstStyle/>
+        <a:p>
+          <a:pPr>
+            <a:defRPr sz="1100">
+              <a:solidFill>
+                <a:srgbClr val="6B7675"/>
+              </a:solidFill>
+              <a:latin typeface="+mn-lt"/>
+              <a:cs typeface="+mn-lt"/>
+            </a:defRPr>
+          </a:pPr>
+          <a:endParaRPr lang="en-US"/>
+        </a:p>
+      </c:txPr>
+    </c:legend>
     <c:plotVisOnly val="1"/>
     <c:dispBlanksAs val="span"/>
   </c:chart>
@@ -1028,6 +2498,1310 @@
 </file>
 
 <file path=ppt/charts/chart5.xml><?xml version="1.0" encoding="utf-8"?>
+<c:chartSpace xmlns:c="http://schemas.openxmlformats.org/drawingml/2006/chart" xmlns:a="http://schemas.openxmlformats.org/drawingml/2006/main" xmlns:r="http://schemas.openxmlformats.org/officeDocument/2006/relationships">
+  <c:date1904 val="0"/>
+  <c:roundedCorners val="1"/>
+  <c:chart>
+    <c:autoTitleDeleted val="1"/>
+    <c:plotArea>
+      <c:layout/>
+      <c:barChart>
+        <c:barDir val="col"/>
+        <c:grouping val="clustered"/>
+        <c:varyColors val="0"/>
+        <c:ser>
+          <c:idx val="0"/>
+          <c:order val="0"/>
+          <c:tx>
+            <c:strRef>
+              <c:f>Sheet1!$B$1</c:f>
+              <c:strCache>
+                <c:ptCount val="1"/>
+                <c:pt idx="0">
+                  <c:v>قيمة المفوتر</c:v>
+                </c:pt>
+              </c:strCache>
+            </c:strRef>
+          </c:tx>
+          <c:spPr>
+            <a:solidFill>
+              <a:srgbClr val="2D6A66"/>
+            </a:solidFill>
+            <a:effectLst/>
+          </c:spPr>
+          <c:invertIfNegative val="0"/>
+          <c:dLbls>
+            <c:numFmt formatCode="#,##0" sourceLinked="0"/>
+            <c:txPr>
+              <a:bodyPr/>
+              <a:lstStyle/>
+              <a:p>
+                <a:pPr>
+                  <a:defRPr b="1" i="0" strike="noStrike" sz="1100" u="none">
+                    <a:solidFill>
+                      <a:srgbClr val="1E2B2A"/>
+                    </a:solidFill>
+                    <a:latin typeface="+mn-lt"/>
+                  </a:defRPr>
+                </a:pPr>
+              </a:p>
+            </c:txPr>
+            <c:showLegendKey val="0"/>
+            <c:showVal val="1"/>
+            <c:showCatName val="0"/>
+            <c:showSerName val="0"/>
+            <c:showPercent val="0"/>
+            <c:showBubbleSize val="0"/>
+            <c:showLeaderLines val="0"/>
+          </c:dLbls>
+          <c:cat>
+            <c:multiLvlStrRef>
+              <c:f>Sheet1!$A$2:$A$3</c:f>
+              <c:multiLvlStrCache>
+                <c:ptCount val="2"/>
+                <c:lvl>
+                  <c:pt idx="0">
+                    <c:v>الفترة الحالية</c:v>
+                  </c:pt>
+                  <c:pt idx="1">
+                    <c:v>الإجمالي</c:v>
+                  </c:pt>
+                </c:lvl>
+              </c:multiLvlStrCache>
+            </c:multiLvlStrRef>
+          </c:cat>
+          <c:val>
+            <c:numRef>
+              <c:f>Sheet1!$B$2:$B$3</c:f>
+              <c:numCache>
+                <c:formatCode>General</c:formatCode>
+                <c:ptCount val="2"/>
+                <c:pt idx="0">
+                  <c:v>3399</c:v>
+                </c:pt>
+                <c:pt idx="1">
+                  <c:v>3399</c:v>
+                </c:pt>
+              </c:numCache>
+            </c:numRef>
+          </c:val>
+        </c:ser>
+        <c:ser>
+          <c:idx val="1"/>
+          <c:order val="1"/>
+          <c:tx>
+            <c:strRef>
+              <c:f>Sheet1!$C$1</c:f>
+              <c:strCache>
+                <c:ptCount val="1"/>
+                <c:pt idx="0">
+                  <c:v>المستهدف</c:v>
+                </c:pt>
+              </c:strCache>
+            </c:strRef>
+          </c:tx>
+          <c:spPr>
+            <a:solidFill>
+              <a:srgbClr val="86B19A"/>
+            </a:solidFill>
+            <a:effectLst/>
+          </c:spPr>
+          <c:invertIfNegative val="0"/>
+          <c:dLbls>
+            <c:numFmt formatCode="#,##0" sourceLinked="0"/>
+            <c:txPr>
+              <a:bodyPr/>
+              <a:lstStyle/>
+              <a:p>
+                <a:pPr>
+                  <a:defRPr b="1" i="0" strike="noStrike" sz="1100" u="none">
+                    <a:solidFill>
+                      <a:srgbClr val="1E2B2A"/>
+                    </a:solidFill>
+                    <a:latin typeface="+mn-lt"/>
+                  </a:defRPr>
+                </a:pPr>
+              </a:p>
+            </c:txPr>
+            <c:showLegendKey val="0"/>
+            <c:showVal val="1"/>
+            <c:showCatName val="0"/>
+            <c:showSerName val="0"/>
+            <c:showPercent val="0"/>
+            <c:showBubbleSize val="0"/>
+            <c:showLeaderLines val="0"/>
+          </c:dLbls>
+          <c:cat>
+            <c:multiLvlStrRef>
+              <c:f>Sheet1!$A$2:$A$3</c:f>
+              <c:multiLvlStrCache>
+                <c:ptCount val="2"/>
+                <c:lvl>
+                  <c:pt idx="0">
+                    <c:v>الفترة الحالية</c:v>
+                  </c:pt>
+                  <c:pt idx="1">
+                    <c:v>الإجمالي</c:v>
+                  </c:pt>
+                </c:lvl>
+              </c:multiLvlStrCache>
+            </c:multiLvlStrRef>
+          </c:cat>
+          <c:val>
+            <c:numRef>
+              <c:f>Sheet1!$C$2:$C$3</c:f>
+              <c:numCache>
+                <c:formatCode>General</c:formatCode>
+                <c:ptCount val="2"/>
+                <c:pt idx="0">
+                  <c:v>3368</c:v>
+                </c:pt>
+                <c:pt idx="1">
+                  <c:v>3364</c:v>
+                </c:pt>
+              </c:numCache>
+            </c:numRef>
+          </c:val>
+        </c:ser>
+        <c:dLbls>
+          <c:numFmt formatCode="#,##0" sourceLinked="0"/>
+          <c:txPr>
+            <a:bodyPr/>
+            <a:lstStyle/>
+            <a:p>
+              <a:pPr>
+                <a:defRPr b="1" i="0" strike="noStrike" sz="1100" u="none">
+                  <a:solidFill>
+                    <a:srgbClr val="1E2B2A"/>
+                  </a:solidFill>
+                  <a:latin typeface="+mn-lt"/>
+                </a:defRPr>
+              </a:pPr>
+            </a:p>
+          </c:txPr>
+          <c:showLegendKey val="0"/>
+          <c:showVal val="1"/>
+          <c:showCatName val="0"/>
+          <c:showSerName val="0"/>
+          <c:showPercent val="0"/>
+          <c:showBubbleSize val="0"/>
+          <c:showLeaderLines val="0"/>
+        </c:dLbls>
+        <c:gapWidth val="110"/>
+        <c:overlap val="-10"/>
+        <c:axId val="2094734554"/>
+        <c:axId val="2094734552"/>
+        <c:axId val="2094734556"/>
+      </c:barChart>
+      <c:catAx>
+        <c:axId val="2094734554"/>
+        <c:scaling>
+          <c:orientation val="maxMin"/>
+        </c:scaling>
+        <c:delete val="0"/>
+        <c:axPos val="b"/>
+        <c:numFmt formatCode="General" sourceLinked="1"/>
+        <c:majorTickMark val="out"/>
+        <c:minorTickMark val="none"/>
+        <c:tickLblPos val="low"/>
+        <c:spPr>
+          <a:ln w="12700" cap="flat">
+            <a:solidFill>
+              <a:srgbClr val="888888"/>
+            </a:solidFill>
+            <a:prstDash val="solid"/>
+            <a:round/>
+          </a:ln>
+        </c:spPr>
+        <c:txPr>
+          <a:bodyPr/>
+          <a:lstStyle/>
+          <a:p>
+            <a:pPr>
+              <a:defRPr sz="1100" b="0" i="0" u="none" strike="noStrike">
+                <a:solidFill>
+                  <a:srgbClr val="1E2B2A"/>
+                </a:solidFill>
+                <a:latin typeface="+mn-lt"/>
+              </a:defRPr>
+            </a:pPr>
+            <a:endParaRPr lang="en-US"/>
+          </a:p>
+        </c:txPr>
+        <c:crossAx val="2094734552"/>
+        <c:crosses val="autoZero"/>
+        <c:auto val="1"/>
+        <c:lblAlgn val="ctr"/>
+        <c:noMultiLvlLbl val="1"/>
+      </c:catAx>
+      <c:valAx>
+        <c:axId val="2094734552"/>
+        <c:scaling>
+          <c:orientation val="minMax"/>
+          <c:max val="4000"/>
+          <c:min val="0"/>
+        </c:scaling>
+        <c:delete val="1"/>
+        <c:axPos val="l"/>
+        <c:numFmt formatCode="General" sourceLinked="0"/>
+        <c:majorTickMark val="out"/>
+        <c:minorTickMark val="none"/>
+        <c:tickLblPos val="nextTo"/>
+        <c:spPr>
+          <a:ln w="12700" cap="flat">
+            <a:solidFill>
+              <a:srgbClr val="888888"/>
+            </a:solidFill>
+            <a:prstDash val="solid"/>
+            <a:round/>
+          </a:ln>
+        </c:spPr>
+        <c:txPr>
+          <a:bodyPr/>
+          <a:lstStyle/>
+          <a:p>
+            <a:pPr>
+              <a:defRPr sz="1200" b="0" i="0" u="none" strike="noStrike">
+                <a:solidFill>
+                  <a:srgbClr val="000000"/>
+                </a:solidFill>
+                <a:latin typeface="Arial"/>
+              </a:defRPr>
+            </a:pPr>
+            <a:endParaRPr lang="en-US"/>
+          </a:p>
+        </c:txPr>
+        <c:crossAx val="2094734554"/>
+        <c:crosses val="autoZero"/>
+        <c:crossBetween val="between"/>
+      </c:valAx>
+      <c:spPr>
+        <a:noFill/>
+        <a:ln>
+          <a:noFill/>
+        </a:ln>
+        <a:effectLst/>
+      </c:spPr>
+    </c:plotArea>
+    <c:legend>
+      <c:legendPos val="t"/>
+      <c:overlay val="0"/>
+      <c:txPr>
+        <a:bodyPr/>
+        <a:lstStyle/>
+        <a:p>
+          <a:pPr>
+            <a:defRPr sz="1100">
+              <a:solidFill>
+                <a:srgbClr val="6B7675"/>
+              </a:solidFill>
+              <a:latin typeface="+mn-lt"/>
+              <a:cs typeface="+mn-lt"/>
+            </a:defRPr>
+          </a:pPr>
+          <a:endParaRPr lang="en-US"/>
+        </a:p>
+      </c:txPr>
+    </c:legend>
+    <c:plotVisOnly val="1"/>
+    <c:dispBlanksAs val="span"/>
+  </c:chart>
+  <c:spPr>
+    <a:noFill/>
+    <a:ln>
+      <a:noFill/>
+    </a:ln>
+    <a:effectLst/>
+  </c:spPr>
+  <c:externalData r:id="rId1">
+    <c:autoUpdate val="0"/>
+  </c:externalData>
+</c:chartSpace>
+</file>
+
+<file path=ppt/charts/chart6.xml><?xml version="1.0" encoding="utf-8"?>
+<c:chartSpace xmlns:c="http://schemas.openxmlformats.org/drawingml/2006/chart" xmlns:a="http://schemas.openxmlformats.org/drawingml/2006/main" xmlns:r="http://schemas.openxmlformats.org/officeDocument/2006/relationships">
+  <c:date1904 val="0"/>
+  <c:roundedCorners val="1"/>
+  <c:chart>
+    <c:autoTitleDeleted val="1"/>
+    <c:plotArea>
+      <c:layout/>
+      <c:barChart>
+        <c:barDir val="col"/>
+        <c:grouping val="clustered"/>
+        <c:varyColors val="0"/>
+        <c:ser>
+          <c:idx val="0"/>
+          <c:order val="0"/>
+          <c:tx>
+            <c:strRef>
+              <c:f>Sheet1!$B$1</c:f>
+              <c:strCache>
+                <c:ptCount val="1"/>
+                <c:pt idx="0">
+                  <c:v>إجمالي المحصل</c:v>
+                </c:pt>
+              </c:strCache>
+            </c:strRef>
+          </c:tx>
+          <c:spPr>
+            <a:solidFill>
+              <a:srgbClr val="2D6A66"/>
+            </a:solidFill>
+            <a:effectLst/>
+          </c:spPr>
+          <c:invertIfNegative val="0"/>
+          <c:dLbls>
+            <c:numFmt formatCode="#,##0" sourceLinked="0"/>
+            <c:txPr>
+              <a:bodyPr/>
+              <a:lstStyle/>
+              <a:p>
+                <a:pPr>
+                  <a:defRPr b="1" i="0" strike="noStrike" sz="1100" u="none">
+                    <a:solidFill>
+                      <a:srgbClr val="1E2B2A"/>
+                    </a:solidFill>
+                    <a:latin typeface="+mn-lt"/>
+                  </a:defRPr>
+                </a:pPr>
+              </a:p>
+            </c:txPr>
+            <c:showLegendKey val="0"/>
+            <c:showVal val="1"/>
+            <c:showCatName val="0"/>
+            <c:showSerName val="0"/>
+            <c:showPercent val="0"/>
+            <c:showBubbleSize val="0"/>
+            <c:showLeaderLines val="0"/>
+          </c:dLbls>
+          <c:cat>
+            <c:multiLvlStrRef>
+              <c:f>Sheet1!$A$2:$A$4</c:f>
+              <c:multiLvlStrCache>
+                <c:ptCount val="3"/>
+                <c:lvl>
+                  <c:pt idx="0">
+                    <c:v>السنة الحالية</c:v>
+                  </c:pt>
+                  <c:pt idx="1">
+                    <c:v>السنوات السابقة</c:v>
+                  </c:pt>
+                  <c:pt idx="2">
+                    <c:v>إجمالي المحصل</c:v>
+                  </c:pt>
+                </c:lvl>
+              </c:multiLvlStrCache>
+            </c:multiLvlStrRef>
+          </c:cat>
+          <c:val>
+            <c:numRef>
+              <c:f>Sheet1!$B$2:$B$4</c:f>
+              <c:numCache>
+                <c:formatCode>General</c:formatCode>
+                <c:ptCount val="3"/>
+                <c:pt idx="0">
+                  <c:v>3305</c:v>
+                </c:pt>
+                <c:pt idx="1">
+                  <c:v>466</c:v>
+                </c:pt>
+                <c:pt idx="2">
+                  <c:v>2955</c:v>
+                </c:pt>
+              </c:numCache>
+            </c:numRef>
+          </c:val>
+        </c:ser>
+        <c:dLbls>
+          <c:numFmt formatCode="#,##0" sourceLinked="0"/>
+          <c:txPr>
+            <a:bodyPr/>
+            <a:lstStyle/>
+            <a:p>
+              <a:pPr>
+                <a:defRPr b="1" i="0" strike="noStrike" sz="1100" u="none">
+                  <a:solidFill>
+                    <a:srgbClr val="1E2B2A"/>
+                  </a:solidFill>
+                  <a:latin typeface="+mn-lt"/>
+                </a:defRPr>
+              </a:pPr>
+            </a:p>
+          </c:txPr>
+          <c:showLegendKey val="0"/>
+          <c:showVal val="1"/>
+          <c:showCatName val="0"/>
+          <c:showSerName val="0"/>
+          <c:showPercent val="0"/>
+          <c:showBubbleSize val="0"/>
+          <c:showLeaderLines val="0"/>
+        </c:dLbls>
+        <c:gapWidth val="90"/>
+        <c:overlap val="-10"/>
+        <c:axId val="2094734554"/>
+        <c:axId val="2094734552"/>
+        <c:axId val="2094734556"/>
+      </c:barChart>
+      <c:catAx>
+        <c:axId val="2094734554"/>
+        <c:scaling>
+          <c:orientation val="maxMin"/>
+        </c:scaling>
+        <c:delete val="0"/>
+        <c:axPos val="b"/>
+        <c:numFmt formatCode="General" sourceLinked="1"/>
+        <c:majorTickMark val="out"/>
+        <c:minorTickMark val="none"/>
+        <c:tickLblPos val="low"/>
+        <c:spPr>
+          <a:ln w="12700" cap="flat">
+            <a:solidFill>
+              <a:srgbClr val="888888"/>
+            </a:solidFill>
+            <a:prstDash val="solid"/>
+            <a:round/>
+          </a:ln>
+        </c:spPr>
+        <c:txPr>
+          <a:bodyPr/>
+          <a:lstStyle/>
+          <a:p>
+            <a:pPr>
+              <a:defRPr sz="1100" b="0" i="0" u="none" strike="noStrike">
+                <a:solidFill>
+                  <a:srgbClr val="1E2B2A"/>
+                </a:solidFill>
+                <a:latin typeface="+mn-lt"/>
+              </a:defRPr>
+            </a:pPr>
+            <a:endParaRPr lang="en-US"/>
+          </a:p>
+        </c:txPr>
+        <c:crossAx val="2094734552"/>
+        <c:crosses val="autoZero"/>
+        <c:auto val="1"/>
+        <c:lblAlgn val="ctr"/>
+        <c:noMultiLvlLbl val="1"/>
+      </c:catAx>
+      <c:valAx>
+        <c:axId val="2094734552"/>
+        <c:scaling>
+          <c:orientation val="minMax"/>
+          <c:max val="3900"/>
+          <c:min val="0"/>
+        </c:scaling>
+        <c:delete val="1"/>
+        <c:axPos val="l"/>
+        <c:numFmt formatCode="General" sourceLinked="0"/>
+        <c:majorTickMark val="out"/>
+        <c:minorTickMark val="none"/>
+        <c:tickLblPos val="nextTo"/>
+        <c:spPr>
+          <a:ln w="12700" cap="flat">
+            <a:solidFill>
+              <a:srgbClr val="888888"/>
+            </a:solidFill>
+            <a:prstDash val="solid"/>
+            <a:round/>
+          </a:ln>
+        </c:spPr>
+        <c:txPr>
+          <a:bodyPr/>
+          <a:lstStyle/>
+          <a:p>
+            <a:pPr>
+              <a:defRPr sz="1200" b="0" i="0" u="none" strike="noStrike">
+                <a:solidFill>
+                  <a:srgbClr val="000000"/>
+                </a:solidFill>
+                <a:latin typeface="Arial"/>
+              </a:defRPr>
+            </a:pPr>
+            <a:endParaRPr lang="en-US"/>
+          </a:p>
+        </c:txPr>
+        <c:crossAx val="2094734554"/>
+        <c:crosses val="autoZero"/>
+        <c:crossBetween val="between"/>
+      </c:valAx>
+      <c:spPr>
+        <a:noFill/>
+        <a:ln>
+          <a:noFill/>
+        </a:ln>
+        <a:effectLst/>
+      </c:spPr>
+    </c:plotArea>
+    <c:plotVisOnly val="1"/>
+    <c:dispBlanksAs val="span"/>
+  </c:chart>
+  <c:spPr>
+    <a:noFill/>
+    <a:ln>
+      <a:noFill/>
+    </a:ln>
+    <a:effectLst/>
+  </c:spPr>
+  <c:externalData r:id="rId1">
+    <c:autoUpdate val="0"/>
+  </c:externalData>
+</c:chartSpace>
+</file>
+
+<file path=ppt/charts/chart7.xml><?xml version="1.0" encoding="utf-8"?>
+<c:chartSpace xmlns:c="http://schemas.openxmlformats.org/drawingml/2006/chart" xmlns:a="http://schemas.openxmlformats.org/drawingml/2006/main" xmlns:r="http://schemas.openxmlformats.org/officeDocument/2006/relationships">
+  <c:date1904 val="0"/>
+  <c:roundedCorners val="1"/>
+  <c:chart>
+    <c:autoTitleDeleted val="1"/>
+    <c:plotArea>
+      <c:layout/>
+      <c:barChart>
+        <c:barDir val="col"/>
+        <c:grouping val="clustered"/>
+        <c:varyColors val="0"/>
+        <c:ser>
+          <c:idx val="0"/>
+          <c:order val="0"/>
+          <c:tx>
+            <c:strRef>
+              <c:f>Sheet1!$B$1</c:f>
+              <c:strCache>
+                <c:ptCount val="1"/>
+                <c:pt idx="0">
+                  <c:v>الفترة الحالية</c:v>
+                </c:pt>
+              </c:strCache>
+            </c:strRef>
+          </c:tx>
+          <c:spPr>
+            <a:solidFill>
+              <a:srgbClr val="2D6A66"/>
+            </a:solidFill>
+            <a:effectLst/>
+          </c:spPr>
+          <c:invertIfNegative val="0"/>
+          <c:dLbls>
+            <c:numFmt formatCode="0&quot;%&quot;" sourceLinked="0"/>
+            <c:txPr>
+              <a:bodyPr/>
+              <a:lstStyle/>
+              <a:p>
+                <a:pPr>
+                  <a:defRPr b="1" i="0" strike="noStrike" sz="1100" u="none">
+                    <a:solidFill>
+                      <a:srgbClr val="1E2B2A"/>
+                    </a:solidFill>
+                    <a:latin typeface="+mn-lt"/>
+                  </a:defRPr>
+                </a:pPr>
+              </a:p>
+            </c:txPr>
+            <c:showLegendKey val="0"/>
+            <c:showVal val="1"/>
+            <c:showCatName val="0"/>
+            <c:showSerName val="0"/>
+            <c:showPercent val="0"/>
+            <c:showBubbleSize val="0"/>
+            <c:showLeaderLines val="0"/>
+          </c:dLbls>
+          <c:cat>
+            <c:multiLvlStrRef>
+              <c:f>Sheet1!$A$2:$A$4</c:f>
+              <c:multiLvlStrCache>
+                <c:ptCount val="3"/>
+                <c:lvl>
+                  <c:pt idx="0">
+                    <c:v>المفوترة (الإعتماد الأصلي)</c:v>
+                  </c:pt>
+                  <c:pt idx="1">
+                    <c:v>المفوترة (بعد التعديل)</c:v>
+                  </c:pt>
+                  <c:pt idx="2">
+                    <c:v>المحصلة (بعد التعديل)</c:v>
+                  </c:pt>
+                </c:lvl>
+              </c:multiLvlStrCache>
+            </c:multiLvlStrRef>
+          </c:cat>
+          <c:val>
+            <c:numRef>
+              <c:f>Sheet1!$B$2:$B$4</c:f>
+              <c:numCache>
+                <c:formatCode>General</c:formatCode>
+                <c:ptCount val="3"/>
+                <c:pt idx="0">
+                  <c:v>49</c:v>
+                </c:pt>
+                <c:pt idx="1">
+                  <c:v>52</c:v>
+                </c:pt>
+                <c:pt idx="2">
+                  <c:v>71</c:v>
+                </c:pt>
+              </c:numCache>
+            </c:numRef>
+          </c:val>
+        </c:ser>
+        <c:ser>
+          <c:idx val="1"/>
+          <c:order val="1"/>
+          <c:tx>
+            <c:strRef>
+              <c:f>Sheet1!$C$1</c:f>
+              <c:strCache>
+                <c:ptCount val="1"/>
+                <c:pt idx="0">
+                  <c:v>الإجمالي</c:v>
+                </c:pt>
+              </c:strCache>
+            </c:strRef>
+          </c:tx>
+          <c:spPr>
+            <a:solidFill>
+              <a:srgbClr val="86B19A"/>
+            </a:solidFill>
+            <a:effectLst/>
+          </c:spPr>
+          <c:invertIfNegative val="0"/>
+          <c:dLbls>
+            <c:numFmt formatCode="0&quot;%&quot;" sourceLinked="0"/>
+            <c:txPr>
+              <a:bodyPr/>
+              <a:lstStyle/>
+              <a:p>
+                <a:pPr>
+                  <a:defRPr b="1" i="0" strike="noStrike" sz="1100" u="none">
+                    <a:solidFill>
+                      <a:srgbClr val="1E2B2A"/>
+                    </a:solidFill>
+                    <a:latin typeface="+mn-lt"/>
+                  </a:defRPr>
+                </a:pPr>
+              </a:p>
+            </c:txPr>
+            <c:showLegendKey val="0"/>
+            <c:showVal val="1"/>
+            <c:showCatName val="0"/>
+            <c:showSerName val="0"/>
+            <c:showPercent val="0"/>
+            <c:showBubbleSize val="0"/>
+            <c:showLeaderLines val="0"/>
+          </c:dLbls>
+          <c:cat>
+            <c:multiLvlStrRef>
+              <c:f>Sheet1!$A$2:$A$4</c:f>
+              <c:multiLvlStrCache>
+                <c:ptCount val="3"/>
+                <c:lvl>
+                  <c:pt idx="0">
+                    <c:v>المفوترة (الإعتماد الأصلي)</c:v>
+                  </c:pt>
+                  <c:pt idx="1">
+                    <c:v>المفوترة (بعد التعديل)</c:v>
+                  </c:pt>
+                  <c:pt idx="2">
+                    <c:v>المحصلة (بعد التعديل)</c:v>
+                  </c:pt>
+                </c:lvl>
+              </c:multiLvlStrCache>
+            </c:multiLvlStrRef>
+          </c:cat>
+          <c:val>
+            <c:numRef>
+              <c:f>Sheet1!$C$2:$C$4</c:f>
+              <c:numCache>
+                <c:formatCode>General</c:formatCode>
+                <c:ptCount val="3"/>
+                <c:pt idx="0">
+                  <c:v>70</c:v>
+                </c:pt>
+                <c:pt idx="1">
+                  <c:v>50</c:v>
+                </c:pt>
+                <c:pt idx="2">
+                  <c:v>76</c:v>
+                </c:pt>
+              </c:numCache>
+            </c:numRef>
+          </c:val>
+        </c:ser>
+        <c:dLbls>
+          <c:numFmt formatCode="0&quot;%&quot;" sourceLinked="0"/>
+          <c:txPr>
+            <a:bodyPr/>
+            <a:lstStyle/>
+            <a:p>
+              <a:pPr>
+                <a:defRPr b="1" i="0" strike="noStrike" sz="1100" u="none">
+                  <a:solidFill>
+                    <a:srgbClr val="1E2B2A"/>
+                  </a:solidFill>
+                  <a:latin typeface="+mn-lt"/>
+                </a:defRPr>
+              </a:pPr>
+            </a:p>
+          </c:txPr>
+          <c:showLegendKey val="0"/>
+          <c:showVal val="1"/>
+          <c:showCatName val="0"/>
+          <c:showSerName val="0"/>
+          <c:showPercent val="0"/>
+          <c:showBubbleSize val="0"/>
+          <c:showLeaderLines val="0"/>
+        </c:dLbls>
+        <c:gapWidth val="70"/>
+        <c:overlap val="-10"/>
+        <c:axId val="2094734554"/>
+        <c:axId val="2094734552"/>
+        <c:axId val="2094734556"/>
+      </c:barChart>
+      <c:catAx>
+        <c:axId val="2094734554"/>
+        <c:scaling>
+          <c:orientation val="maxMin"/>
+        </c:scaling>
+        <c:delete val="0"/>
+        <c:axPos val="b"/>
+        <c:numFmt formatCode="General" sourceLinked="1"/>
+        <c:majorTickMark val="out"/>
+        <c:minorTickMark val="none"/>
+        <c:tickLblPos val="low"/>
+        <c:spPr>
+          <a:ln w="12700" cap="flat">
+            <a:solidFill>
+              <a:srgbClr val="888888"/>
+            </a:solidFill>
+            <a:prstDash val="solid"/>
+            <a:round/>
+          </a:ln>
+        </c:spPr>
+        <c:txPr>
+          <a:bodyPr/>
+          <a:lstStyle/>
+          <a:p>
+            <a:pPr>
+              <a:defRPr sz="1100" b="0" i="0" u="none" strike="noStrike">
+                <a:solidFill>
+                  <a:srgbClr val="1E2B2A"/>
+                </a:solidFill>
+                <a:latin typeface="+mn-lt"/>
+              </a:defRPr>
+            </a:pPr>
+            <a:endParaRPr lang="en-US"/>
+          </a:p>
+        </c:txPr>
+        <c:crossAx val="2094734552"/>
+        <c:crosses val="autoZero"/>
+        <c:auto val="1"/>
+        <c:lblAlgn val="ctr"/>
+        <c:noMultiLvlLbl val="1"/>
+      </c:catAx>
+      <c:valAx>
+        <c:axId val="2094734552"/>
+        <c:scaling>
+          <c:orientation val="minMax"/>
+          <c:max val="100"/>
+          <c:min val="0"/>
+        </c:scaling>
+        <c:delete val="1"/>
+        <c:axPos val="l"/>
+        <c:numFmt formatCode="General" sourceLinked="0"/>
+        <c:majorTickMark val="out"/>
+        <c:minorTickMark val="none"/>
+        <c:tickLblPos val="nextTo"/>
+        <c:spPr>
+          <a:ln w="12700" cap="flat">
+            <a:solidFill>
+              <a:srgbClr val="888888"/>
+            </a:solidFill>
+            <a:prstDash val="solid"/>
+            <a:round/>
+          </a:ln>
+        </c:spPr>
+        <c:txPr>
+          <a:bodyPr/>
+          <a:lstStyle/>
+          <a:p>
+            <a:pPr>
+              <a:defRPr sz="1200" b="0" i="0" u="none" strike="noStrike">
+                <a:solidFill>
+                  <a:srgbClr val="000000"/>
+                </a:solidFill>
+                <a:latin typeface="Arial"/>
+              </a:defRPr>
+            </a:pPr>
+            <a:endParaRPr lang="en-US"/>
+          </a:p>
+        </c:txPr>
+        <c:crossAx val="2094734554"/>
+        <c:crosses val="autoZero"/>
+        <c:crossBetween val="between"/>
+      </c:valAx>
+      <c:spPr>
+        <a:noFill/>
+        <a:ln>
+          <a:noFill/>
+        </a:ln>
+        <a:effectLst/>
+      </c:spPr>
+    </c:plotArea>
+    <c:legend>
+      <c:legendPos val="t"/>
+      <c:overlay val="0"/>
+      <c:txPr>
+        <a:bodyPr/>
+        <a:lstStyle/>
+        <a:p>
+          <a:pPr>
+            <a:defRPr sz="1100">
+              <a:solidFill>
+                <a:srgbClr val="6B7675"/>
+              </a:solidFill>
+              <a:latin typeface="+mn-lt"/>
+              <a:cs typeface="+mn-lt"/>
+            </a:defRPr>
+          </a:pPr>
+          <a:endParaRPr lang="en-US"/>
+        </a:p>
+      </c:txPr>
+    </c:legend>
+    <c:plotVisOnly val="1"/>
+    <c:dispBlanksAs val="span"/>
+  </c:chart>
+  <c:spPr>
+    <a:noFill/>
+    <a:ln>
+      <a:noFill/>
+    </a:ln>
+    <a:effectLst/>
+  </c:spPr>
+  <c:externalData r:id="rId1">
+    <c:autoUpdate val="0"/>
+  </c:externalData>
+</c:chartSpace>
+</file>
+
+<file path=ppt/charts/chart8.xml><?xml version="1.0" encoding="utf-8"?>
+<c:chartSpace xmlns:c="http://schemas.openxmlformats.org/drawingml/2006/chart" xmlns:a="http://schemas.openxmlformats.org/drawingml/2006/main" xmlns:r="http://schemas.openxmlformats.org/officeDocument/2006/relationships">
+  <c:date1904 val="0"/>
+  <c:roundedCorners val="1"/>
+  <c:chart>
+    <c:autoTitleDeleted val="1"/>
+    <c:plotArea>
+      <c:layout/>
+      <c:barChart>
+        <c:barDir val="col"/>
+        <c:grouping val="clustered"/>
+        <c:varyColors val="0"/>
+        <c:ser>
+          <c:idx val="0"/>
+          <c:order val="0"/>
+          <c:tx>
+            <c:strRef>
+              <c:f>Sheet1!$B$1</c:f>
+              <c:strCache>
+                <c:ptCount val="1"/>
+                <c:pt idx="0">
+                  <c:v>القيمة</c:v>
+                </c:pt>
+              </c:strCache>
+            </c:strRef>
+          </c:tx>
+          <c:spPr>
+            <a:solidFill>
+              <a:srgbClr val="2D6A66"/>
+            </a:solidFill>
+            <a:effectLst/>
+          </c:spPr>
+          <c:invertIfNegative val="0"/>
+          <c:dLbls>
+            <c:numFmt formatCode="#,##0" sourceLinked="0"/>
+            <c:txPr>
+              <a:bodyPr/>
+              <a:lstStyle/>
+              <a:p>
+                <a:pPr>
+                  <a:defRPr b="1" i="0" strike="noStrike" sz="1000" u="none">
+                    <a:solidFill>
+                      <a:srgbClr val="1E2B2A"/>
+                    </a:solidFill>
+                    <a:latin typeface="+mn-lt"/>
+                  </a:defRPr>
+                </a:pPr>
+              </a:p>
+            </c:txPr>
+            <c:showLegendKey val="0"/>
+            <c:showVal val="1"/>
+            <c:showCatName val="0"/>
+            <c:showSerName val="0"/>
+            <c:showPercent val="0"/>
+            <c:showBubbleSize val="0"/>
+            <c:showLeaderLines val="0"/>
+          </c:dLbls>
+          <c:cat>
+            <c:multiLvlStrRef>
+              <c:f>Sheet1!$A$2:$A$4</c:f>
+              <c:multiLvlStrCache>
+                <c:ptCount val="3"/>
+                <c:lvl>
+                  <c:pt idx="0">
+                    <c:v>المفوترة (الإعتماد الأصلي)</c:v>
+                  </c:pt>
+                  <c:pt idx="1">
+                    <c:v>المفوترة (بعد التعديل)</c:v>
+                  </c:pt>
+                  <c:pt idx="2">
+                    <c:v>المحصلة (بعد التعديل)</c:v>
+                  </c:pt>
+                </c:lvl>
+              </c:multiLvlStrCache>
+            </c:multiLvlStrRef>
+          </c:cat>
+          <c:val>
+            <c:numRef>
+              <c:f>Sheet1!$B$2:$B$4</c:f>
+              <c:numCache>
+                <c:formatCode>General</c:formatCode>
+                <c:ptCount val="3"/>
+                <c:pt idx="0">
+                  <c:v>3399</c:v>
+                </c:pt>
+                <c:pt idx="1">
+                  <c:v>3399</c:v>
+                </c:pt>
+                <c:pt idx="2">
+                  <c:v>2955</c:v>
+                </c:pt>
+              </c:numCache>
+            </c:numRef>
+          </c:val>
+        </c:ser>
+        <c:ser>
+          <c:idx val="1"/>
+          <c:order val="1"/>
+          <c:tx>
+            <c:strRef>
+              <c:f>Sheet1!$C$1</c:f>
+              <c:strCache>
+                <c:ptCount val="1"/>
+                <c:pt idx="0">
+                  <c:v>المستهدف (الفترة الحالية)</c:v>
+                </c:pt>
+              </c:strCache>
+            </c:strRef>
+          </c:tx>
+          <c:spPr>
+            <a:solidFill>
+              <a:srgbClr val="86B19A"/>
+            </a:solidFill>
+            <a:effectLst/>
+          </c:spPr>
+          <c:invertIfNegative val="0"/>
+          <c:dLbls>
+            <c:numFmt formatCode="#,##0" sourceLinked="0"/>
+            <c:txPr>
+              <a:bodyPr/>
+              <a:lstStyle/>
+              <a:p>
+                <a:pPr>
+                  <a:defRPr b="1" i="0" strike="noStrike" sz="1000" u="none">
+                    <a:solidFill>
+                      <a:srgbClr val="1E2B2A"/>
+                    </a:solidFill>
+                    <a:latin typeface="+mn-lt"/>
+                  </a:defRPr>
+                </a:pPr>
+              </a:p>
+            </c:txPr>
+            <c:showLegendKey val="0"/>
+            <c:showVal val="1"/>
+            <c:showCatName val="0"/>
+            <c:showSerName val="0"/>
+            <c:showPercent val="0"/>
+            <c:showBubbleSize val="0"/>
+            <c:showLeaderLines val="0"/>
+          </c:dLbls>
+          <c:cat>
+            <c:multiLvlStrRef>
+              <c:f>Sheet1!$A$2:$A$4</c:f>
+              <c:multiLvlStrCache>
+                <c:ptCount val="3"/>
+                <c:lvl>
+                  <c:pt idx="0">
+                    <c:v>المفوترة (الإعتماد الأصلي)</c:v>
+                  </c:pt>
+                  <c:pt idx="1">
+                    <c:v>المفوترة (بعد التعديل)</c:v>
+                  </c:pt>
+                  <c:pt idx="2">
+                    <c:v>المحصلة (بعد التعديل)</c:v>
+                  </c:pt>
+                </c:lvl>
+              </c:multiLvlStrCache>
+            </c:multiLvlStrRef>
+          </c:cat>
+          <c:val>
+            <c:numRef>
+              <c:f>Sheet1!$C$2:$C$4</c:f>
+              <c:numCache>
+                <c:formatCode>General</c:formatCode>
+                <c:ptCount val="3"/>
+                <c:pt idx="0">
+                  <c:v>3993</c:v>
+                </c:pt>
+                <c:pt idx="1">
+                  <c:v>3911</c:v>
+                </c:pt>
+                <c:pt idx="2">
+                  <c:v>3911</c:v>
+                </c:pt>
+              </c:numCache>
+            </c:numRef>
+          </c:val>
+        </c:ser>
+        <c:ser>
+          <c:idx val="2"/>
+          <c:order val="2"/>
+          <c:tx>
+            <c:strRef>
+              <c:f>Sheet1!$D$1</c:f>
+              <c:strCache>
+                <c:ptCount val="1"/>
+                <c:pt idx="0">
+                  <c:v>المستهدف (الإجمالي)</c:v>
+                </c:pt>
+              </c:strCache>
+            </c:strRef>
+          </c:tx>
+          <c:spPr>
+            <a:solidFill>
+              <a:srgbClr val="8A8F8E"/>
+            </a:solidFill>
+            <a:effectLst/>
+          </c:spPr>
+          <c:invertIfNegative val="0"/>
+          <c:dLbls>
+            <c:numFmt formatCode="#,##0" sourceLinked="0"/>
+            <c:txPr>
+              <a:bodyPr/>
+              <a:lstStyle/>
+              <a:p>
+                <a:pPr>
+                  <a:defRPr b="1" i="0" strike="noStrike" sz="1000" u="none">
+                    <a:solidFill>
+                      <a:srgbClr val="1E2B2A"/>
+                    </a:solidFill>
+                    <a:latin typeface="+mn-lt"/>
+                  </a:defRPr>
+                </a:pPr>
+              </a:p>
+            </c:txPr>
+            <c:showLegendKey val="0"/>
+            <c:showVal val="1"/>
+            <c:showCatName val="0"/>
+            <c:showSerName val="0"/>
+            <c:showPercent val="0"/>
+            <c:showBubbleSize val="0"/>
+            <c:showLeaderLines val="0"/>
+          </c:dLbls>
+          <c:cat>
+            <c:multiLvlStrRef>
+              <c:f>Sheet1!$A$2:$A$4</c:f>
+              <c:multiLvlStrCache>
+                <c:ptCount val="3"/>
+                <c:lvl>
+                  <c:pt idx="0">
+                    <c:v>المفوترة (الإعتماد الأصلي)</c:v>
+                  </c:pt>
+                  <c:pt idx="1">
+                    <c:v>المفوترة (بعد التعديل)</c:v>
+                  </c:pt>
+                  <c:pt idx="2">
+                    <c:v>المحصلة (بعد التعديل)</c:v>
+                  </c:pt>
+                </c:lvl>
+              </c:multiLvlStrCache>
+            </c:multiLvlStrRef>
+          </c:cat>
+          <c:val>
+            <c:numRef>
+              <c:f>Sheet1!$D$2:$D$4</c:f>
+              <c:numCache>
+                <c:formatCode>General</c:formatCode>
+                <c:ptCount val="3"/>
+                <c:pt idx="0">
+                  <c:v>3593</c:v>
+                </c:pt>
+                <c:pt idx="1">
+                  <c:v>3259</c:v>
+                </c:pt>
+                <c:pt idx="2">
+                  <c:v>3259</c:v>
+                </c:pt>
+              </c:numCache>
+            </c:numRef>
+          </c:val>
+        </c:ser>
+        <c:dLbls>
+          <c:numFmt formatCode="#,##0" sourceLinked="0"/>
+          <c:txPr>
+            <a:bodyPr/>
+            <a:lstStyle/>
+            <a:p>
+              <a:pPr>
+                <a:defRPr b="1" i="0" strike="noStrike" sz="1000" u="none">
+                  <a:solidFill>
+                    <a:srgbClr val="1E2B2A"/>
+                  </a:solidFill>
+                  <a:latin typeface="+mn-lt"/>
+                </a:defRPr>
+              </a:pPr>
+            </a:p>
+          </c:txPr>
+          <c:showLegendKey val="0"/>
+          <c:showVal val="1"/>
+          <c:showCatName val="0"/>
+          <c:showSerName val="0"/>
+          <c:showPercent val="0"/>
+          <c:showBubbleSize val="0"/>
+          <c:showLeaderLines val="0"/>
+        </c:dLbls>
+        <c:gapWidth val="50"/>
+        <c:overlap val="-5"/>
+        <c:axId val="2094734554"/>
+        <c:axId val="2094734552"/>
+        <c:axId val="2094734556"/>
+      </c:barChart>
+      <c:catAx>
+        <c:axId val="2094734554"/>
+        <c:scaling>
+          <c:orientation val="maxMin"/>
+        </c:scaling>
+        <c:delete val="0"/>
+        <c:axPos val="b"/>
+        <c:numFmt formatCode="General" sourceLinked="1"/>
+        <c:majorTickMark val="out"/>
+        <c:minorTickMark val="none"/>
+        <c:tickLblPos val="low"/>
+        <c:spPr>
+          <a:ln w="12700" cap="flat">
+            <a:solidFill>
+              <a:srgbClr val="888888"/>
+            </a:solidFill>
+            <a:prstDash val="solid"/>
+            <a:round/>
+          </a:ln>
+        </c:spPr>
+        <c:txPr>
+          <a:bodyPr/>
+          <a:lstStyle/>
+          <a:p>
+            <a:pPr>
+              <a:defRPr sz="1100" b="0" i="0" u="none" strike="noStrike">
+                <a:solidFill>
+                  <a:srgbClr val="1E2B2A"/>
+                </a:solidFill>
+                <a:latin typeface="+mn-lt"/>
+              </a:defRPr>
+            </a:pPr>
+            <a:endParaRPr lang="en-US"/>
+          </a:p>
+        </c:txPr>
+        <c:crossAx val="2094734552"/>
+        <c:crosses val="autoZero"/>
+        <c:auto val="1"/>
+        <c:lblAlgn val="ctr"/>
+        <c:noMultiLvlLbl val="1"/>
+      </c:catAx>
+      <c:valAx>
+        <c:axId val="2094734552"/>
+        <c:scaling>
+          <c:orientation val="minMax"/>
+          <c:max val="4700"/>
+          <c:min val="0"/>
+        </c:scaling>
+        <c:delete val="1"/>
+        <c:axPos val="l"/>
+        <c:numFmt formatCode="General" sourceLinked="0"/>
+        <c:majorTickMark val="out"/>
+        <c:minorTickMark val="none"/>
+        <c:tickLblPos val="nextTo"/>
+        <c:spPr>
+          <a:ln w="12700" cap="flat">
+            <a:solidFill>
+              <a:srgbClr val="888888"/>
+            </a:solidFill>
+            <a:prstDash val="solid"/>
+            <a:round/>
+          </a:ln>
+        </c:spPr>
+        <c:txPr>
+          <a:bodyPr/>
+          <a:lstStyle/>
+          <a:p>
+            <a:pPr>
+              <a:defRPr sz="1200" b="0" i="0" u="none" strike="noStrike">
+                <a:solidFill>
+                  <a:srgbClr val="000000"/>
+                </a:solidFill>
+                <a:latin typeface="Arial"/>
+              </a:defRPr>
+            </a:pPr>
+            <a:endParaRPr lang="en-US"/>
+          </a:p>
+        </c:txPr>
+        <c:crossAx val="2094734554"/>
+        <c:crosses val="autoZero"/>
+        <c:crossBetween val="between"/>
+      </c:valAx>
+      <c:spPr>
+        <a:noFill/>
+        <a:ln>
+          <a:noFill/>
+        </a:ln>
+        <a:effectLst/>
+      </c:spPr>
+    </c:plotArea>
+    <c:legend>
+      <c:legendPos val="t"/>
+      <c:overlay val="0"/>
+      <c:txPr>
+        <a:bodyPr/>
+        <a:lstStyle/>
+        <a:p>
+          <a:pPr>
+            <a:defRPr sz="1100">
+              <a:solidFill>
+                <a:srgbClr val="6B7675"/>
+              </a:solidFill>
+              <a:latin typeface="+mn-lt"/>
+              <a:cs typeface="+mn-lt"/>
+            </a:defRPr>
+          </a:pPr>
+          <a:endParaRPr lang="en-US"/>
+        </a:p>
+      </c:txPr>
+    </c:legend>
+    <c:plotVisOnly val="1"/>
+    <c:dispBlanksAs val="span"/>
+  </c:chart>
+  <c:spPr>
+    <a:noFill/>
+    <a:ln>
+      <a:noFill/>
+    </a:ln>
+    <a:effectLst/>
+  </c:spPr>
+  <c:externalData r:id="rId1">
+    <c:autoUpdate val="0"/>
+  </c:externalData>
+</c:chartSpace>
+</file>
+
+<file path=ppt/charts/chart9.xml><?xml version="1.0" encoding="utf-8"?>
 <c:chartSpace xmlns:c="http://schemas.openxmlformats.org/drawingml/2006/chart" xmlns:a="http://schemas.openxmlformats.org/drawingml/2006/main" xmlns:r="http://schemas.openxmlformats.org/officeDocument/2006/relationships">
   <c:date1904 val="0"/>
   <c:roundedCorners val="1"/>
@@ -1363,342 +4137,6 @@
 </c:chartSpace>
 </file>
 
-<file path=ppt/charts/chart6.xml><?xml version="1.0" encoding="utf-8"?>
-<c:chartSpace xmlns:c="http://schemas.openxmlformats.org/drawingml/2006/chart" xmlns:a="http://schemas.openxmlformats.org/drawingml/2006/main" xmlns:r="http://schemas.openxmlformats.org/officeDocument/2006/relationships">
-  <c:date1904 val="0"/>
-  <c:roundedCorners val="1"/>
-  <c:chart>
-    <c:autoTitleDeleted val="1"/>
-    <c:plotArea>
-      <c:layout/>
-      <c:barChart>
-        <c:barDir val="bar"/>
-        <c:grouping val="clustered"/>
-        <c:varyColors val="0"/>
-        <c:ser>
-          <c:idx val="0"/>
-          <c:order val="0"/>
-          <c:tx>
-            <c:strRef>
-              <c:f>Sheet1!$B$1</c:f>
-              <c:strCache>
-                <c:ptCount val="1"/>
-                <c:pt idx="0">
-                  <c:v>رصيد المديونية</c:v>
-                </c:pt>
-              </c:strCache>
-            </c:strRef>
-          </c:tx>
-          <c:spPr>
-            <a:solidFill>
-              <a:srgbClr val="2D6A66"/>
-            </a:solidFill>
-            <a:effectLst/>
-          </c:spPr>
-          <c:invertIfNegative val="0"/>
-          <c:dLbls>
-            <c:numFmt formatCode="#,##0" sourceLinked="0"/>
-            <c:txPr>
-              <a:bodyPr/>
-              <a:lstStyle/>
-              <a:p>
-                <a:pPr>
-                  <a:defRPr b="1" i="0" strike="noStrike" sz="1100" u="none">
-                    <a:solidFill>
-                      <a:srgbClr val="1E2B2A"/>
-                    </a:solidFill>
-                    <a:latin typeface="+mn-lt"/>
-                  </a:defRPr>
-                </a:pPr>
-              </a:p>
-            </c:txPr>
-            <c:showLegendKey val="0"/>
-            <c:showVal val="1"/>
-            <c:showCatName val="0"/>
-            <c:showSerName val="0"/>
-            <c:showPercent val="0"/>
-            <c:showBubbleSize val="0"/>
-            <c:showLeaderLines val="0"/>
-          </c:dLbls>
-          <c:cat>
-            <c:multiLvlStrRef>
-              <c:f>Sheet1!$A$2:$A$6</c:f>
-              <c:multiLvlStrCache>
-                <c:ptCount val="5"/>
-                <c:lvl>
-                  <c:pt idx="0">
-                    <c:v>الإيرادات الإستثمارية</c:v>
-                  </c:pt>
-                  <c:pt idx="1">
-                    <c:v>رسوم وتراخيص</c:v>
-                  </c:pt>
-                  <c:pt idx="2">
-                    <c:v>جزاءات وغرامات</c:v>
-                  </c:pt>
-                  <c:pt idx="3">
-                    <c:v>التبغ والإيواء</c:v>
-                  </c:pt>
-                  <c:pt idx="4">
-                    <c:v>أخرى</c:v>
-                  </c:pt>
-                </c:lvl>
-              </c:multiLvlStrCache>
-            </c:multiLvlStrRef>
-          </c:cat>
-          <c:val>
-            <c:numRef>
-              <c:f>Sheet1!$B$2:$B$6</c:f>
-              <c:numCache>
-                <c:formatCode>General</c:formatCode>
-                <c:ptCount val="5"/>
-                <c:pt idx="0">
-                  <c:v>108</c:v>
-                </c:pt>
-                <c:pt idx="1">
-                  <c:v>121</c:v>
-                </c:pt>
-                <c:pt idx="2">
-                  <c:v>124</c:v>
-                </c:pt>
-                <c:pt idx="3">
-                  <c:v>130</c:v>
-                </c:pt>
-                <c:pt idx="4">
-                  <c:v>108</c:v>
-                </c:pt>
-              </c:numCache>
-            </c:numRef>
-          </c:val>
-        </c:ser>
-        <c:ser>
-          <c:idx val="1"/>
-          <c:order val="1"/>
-          <c:tx>
-            <c:strRef>
-              <c:f>Sheet1!$C$1</c:f>
-              <c:strCache>
-                <c:ptCount val="1"/>
-                <c:pt idx="0">
-                  <c:v>ما تم سداده</c:v>
-                </c:pt>
-              </c:strCache>
-            </c:strRef>
-          </c:tx>
-          <c:spPr>
-            <a:solidFill>
-              <a:srgbClr val="86B19A"/>
-            </a:solidFill>
-            <a:effectLst/>
-          </c:spPr>
-          <c:invertIfNegative val="0"/>
-          <c:dLbls>
-            <c:numFmt formatCode="#,##0" sourceLinked="0"/>
-            <c:txPr>
-              <a:bodyPr/>
-              <a:lstStyle/>
-              <a:p>
-                <a:pPr>
-                  <a:defRPr b="1" i="0" strike="noStrike" sz="1100" u="none">
-                    <a:solidFill>
-                      <a:srgbClr val="1E2B2A"/>
-                    </a:solidFill>
-                    <a:latin typeface="+mn-lt"/>
-                  </a:defRPr>
-                </a:pPr>
-              </a:p>
-            </c:txPr>
-            <c:showLegendKey val="0"/>
-            <c:showVal val="1"/>
-            <c:showCatName val="0"/>
-            <c:showSerName val="0"/>
-            <c:showPercent val="0"/>
-            <c:showBubbleSize val="0"/>
-            <c:showLeaderLines val="0"/>
-          </c:dLbls>
-          <c:cat>
-            <c:multiLvlStrRef>
-              <c:f>Sheet1!$A$2:$A$6</c:f>
-              <c:multiLvlStrCache>
-                <c:ptCount val="5"/>
-                <c:lvl>
-                  <c:pt idx="0">
-                    <c:v>الإيرادات الإستثمارية</c:v>
-                  </c:pt>
-                  <c:pt idx="1">
-                    <c:v>رسوم وتراخيص</c:v>
-                  </c:pt>
-                  <c:pt idx="2">
-                    <c:v>جزاءات وغرامات</c:v>
-                  </c:pt>
-                  <c:pt idx="3">
-                    <c:v>التبغ والإيواء</c:v>
-                  </c:pt>
-                  <c:pt idx="4">
-                    <c:v>أخرى</c:v>
-                  </c:pt>
-                </c:lvl>
-              </c:multiLvlStrCache>
-            </c:multiLvlStrRef>
-          </c:cat>
-          <c:val>
-            <c:numRef>
-              <c:f>Sheet1!$C$2:$C$6</c:f>
-              <c:numCache>
-                <c:formatCode>General</c:formatCode>
-                <c:ptCount val="5"/>
-                <c:pt idx="0">
-                  <c:v>277</c:v>
-                </c:pt>
-                <c:pt idx="1">
-                  <c:v>273</c:v>
-                </c:pt>
-                <c:pt idx="2">
-                  <c:v>279</c:v>
-                </c:pt>
-                <c:pt idx="3">
-                  <c:v>283</c:v>
-                </c:pt>
-                <c:pt idx="4">
-                  <c:v>279</c:v>
-                </c:pt>
-              </c:numCache>
-            </c:numRef>
-          </c:val>
-        </c:ser>
-        <c:dLbls>
-          <c:numFmt formatCode="#,##0" sourceLinked="0"/>
-          <c:txPr>
-            <a:bodyPr/>
-            <a:lstStyle/>
-            <a:p>
-              <a:pPr>
-                <a:defRPr b="1" i="0" strike="noStrike" sz="1100" u="none">
-                  <a:solidFill>
-                    <a:srgbClr val="1E2B2A"/>
-                  </a:solidFill>
-                  <a:latin typeface="+mn-lt"/>
-                </a:defRPr>
-              </a:pPr>
-            </a:p>
-          </c:txPr>
-          <c:showLegendKey val="0"/>
-          <c:showVal val="1"/>
-          <c:showCatName val="0"/>
-          <c:showSerName val="0"/>
-          <c:showPercent val="0"/>
-          <c:showBubbleSize val="0"/>
-          <c:showLeaderLines val="0"/>
-        </c:dLbls>
-        <c:gapWidth val="55"/>
-        <c:overlap val="-8"/>
-        <c:axId val="2094734554"/>
-        <c:axId val="2094734552"/>
-        <c:axId val="2094734556"/>
-      </c:barChart>
-      <c:catAx>
-        <c:axId val="2094734554"/>
-        <c:scaling>
-          <c:orientation val="maxMin"/>
-        </c:scaling>
-        <c:delete val="0"/>
-        <c:axPos val="l"/>
-        <c:numFmt formatCode="General" sourceLinked="1"/>
-        <c:majorTickMark val="out"/>
-        <c:minorTickMark val="none"/>
-        <c:tickLblPos val="nextTo"/>
-        <c:spPr>
-          <a:ln w="12700" cap="flat">
-            <a:noFill/>
-            <a:prstDash val="solid"/>
-            <a:round/>
-          </a:ln>
-        </c:spPr>
-        <c:txPr>
-          <a:bodyPr/>
-          <a:lstStyle/>
-          <a:p>
-            <a:pPr>
-              <a:defRPr sz="1100" b="0" i="0" u="none" strike="noStrike">
-                <a:solidFill>
-                  <a:srgbClr val="1E2B2A"/>
-                </a:solidFill>
-                <a:latin typeface="+mn-lt"/>
-              </a:defRPr>
-            </a:pPr>
-            <a:endParaRPr lang="en-US"/>
-          </a:p>
-        </c:txPr>
-        <c:crossAx val="2094734552"/>
-        <c:crosses val="autoZero"/>
-        <c:auto val="1"/>
-        <c:lblAlgn val="ctr"/>
-        <c:noMultiLvlLbl val="1"/>
-      </c:catAx>
-      <c:valAx>
-        <c:axId val="2094734552"/>
-        <c:scaling>
-          <c:orientation val="maxMin"/>
-          <c:max val="400"/>
-          <c:min val="0"/>
-        </c:scaling>
-        <c:delete val="1"/>
-        <c:axPos val="b"/>
-        <c:numFmt formatCode="General" sourceLinked="0"/>
-        <c:majorTickMark val="out"/>
-        <c:minorTickMark val="none"/>
-        <c:tickLblPos val="low"/>
-        <c:spPr>
-          <a:ln w="12700" cap="flat">
-            <a:solidFill>
-              <a:srgbClr val="888888"/>
-            </a:solidFill>
-            <a:prstDash val="solid"/>
-            <a:round/>
-          </a:ln>
-        </c:spPr>
-        <c:txPr>
-          <a:bodyPr/>
-          <a:lstStyle/>
-          <a:p>
-            <a:pPr>
-              <a:defRPr sz="1200" b="0" i="0" u="none" strike="noStrike">
-                <a:solidFill>
-                  <a:srgbClr val="000000"/>
-                </a:solidFill>
-                <a:latin typeface="Arial"/>
-              </a:defRPr>
-            </a:pPr>
-            <a:endParaRPr lang="en-US"/>
-          </a:p>
-        </c:txPr>
-        <c:crossAx val="2094734554"/>
-        <c:crosses val="autoZero"/>
-        <c:crossBetween val="between"/>
-      </c:valAx>
-      <c:spPr>
-        <a:noFill/>
-        <a:ln>
-          <a:noFill/>
-        </a:ln>
-        <a:effectLst/>
-      </c:spPr>
-    </c:plotArea>
-    <c:plotVisOnly val="1"/>
-    <c:dispBlanksAs val="span"/>
-  </c:chart>
-  <c:spPr>
-    <a:noFill/>
-    <a:ln>
-      <a:noFill/>
-    </a:ln>
-    <a:effectLst/>
-  </c:spPr>
-  <c:externalData r:id="rId1">
-    <c:autoUpdate val="0"/>
-  </c:externalData>
-</c:chartSpace>
-</file>
-
 <file path=ppt/notesMasters/notesMaster1.xml><?xml version="1.0" encoding="utf-8"?>
 <p:notesMaster xmlns:a="http://schemas.openxmlformats.org/drawingml/2006/main" xmlns:r="http://schemas.openxmlformats.org/officeDocument/2006/relationships" xmlns:p="http://schemas.openxmlformats.org/presentationml/2006/main">
   <p:cSld>
@@ -2182,7 +4620,7 @@
           <a:p>
             <a:r>
               <a:rPr lang="en-US" dirty="0"/>
-              <a:t>حالة المديونيات — جميع القيم بالمليون ريال. الرسم يقارن رصيد المديونية بما تم سداده لكل تبويب في كل فترة.</a:t>
+              <a:t>تحليل مستهدفات الإيرادات — القيم بالمليون ريال، ونسب التغطية بالنسبة المئوية.</a:t>
             </a:r>
             <a:endParaRPr lang="en-US" dirty="0"/>
           </a:p>
@@ -2206,6 +4644,182 @@
             <a:fld id="{F7021451-1387-4CA6-816F-3879F97B5CBC}" type="slidenum">
               <a:rPr lang="en-US"/>
               <a:t>2</a:t>
+            </a:fld>
+            <a:endParaRPr lang="en-US"/>
+          </a:p>
+        </p:txBody>
+      </p:sp>
+    </p:spTree>
+    <p:extLst>
+      <p:ext uri="{BB962C8B-B14F-4D97-AF65-F5344CB8AC3E}">
+        <p14:creationId xmlns:p14="http://schemas.microsoft.com/office/powerpoint/2010/main" val="1024086991"/>
+      </p:ext>
+    </p:extLst>
+  </p:cSld>
+  <p:clrMapOvr>
+    <a:masterClrMapping/>
+  </p:clrMapOvr>
+</p:notes>
+</file>
+
+<file path=ppt/notesSlides/notesSlide3.xml><?xml version="1.0" encoding="utf-8"?>
+<p:notes xmlns:a="http://schemas.openxmlformats.org/drawingml/2006/main" xmlns:r="http://schemas.openxmlformats.org/officeDocument/2006/relationships" xmlns:p="http://schemas.openxmlformats.org/presentationml/2006/main">
+  <p:cSld>
+    <p:spTree>
+      <p:nvGrpSpPr>
+        <p:cNvPr id="1" name=""/>
+        <p:cNvGrpSpPr/>
+        <p:nvPr/>
+      </p:nvGrpSpPr>
+      <p:grpSpPr>
+        <a:xfrm>
+          <a:off x="0" y="0"/>
+          <a:ext cx="0" cy="0"/>
+          <a:chOff x="0" y="0"/>
+          <a:chExt cx="0" cy="0"/>
+        </a:xfrm>
+      </p:grpSpPr>
+      <p:sp>
+        <p:nvSpPr>
+          <p:cNvPr id="2" name="Slide Image Placeholder 1"/>
+          <p:cNvSpPr>
+            <a:spLocks noGrp="1" noRot="1" noChangeAspect="1"/>
+          </p:cNvSpPr>
+          <p:nvPr>
+            <p:ph type="sldImg"/>
+          </p:nvPr>
+        </p:nvSpPr>
+        <p:spPr/>
+      </p:sp>
+      <p:sp>
+        <p:nvSpPr>
+          <p:cNvPr id="3" name="Notes Placeholder 2"/>
+          <p:cNvSpPr>
+            <a:spLocks noGrp="1"/>
+          </p:cNvSpPr>
+          <p:nvPr>
+            <p:ph type="body" idx="1"/>
+          </p:nvPr>
+        </p:nvSpPr>
+        <p:spPr/>
+        <p:txBody>
+          <a:bodyPr/>
+          <a:lstStyle/>
+          <a:p>
+            <a:r>
+              <a:rPr lang="en-US" dirty="0"/>
+              <a:t>حالة المديونيات — جميع القيم بالمليون ريال. الرسم يقارن رصيد المديونية بما تم سداده لكل تبويب في كل فترة.</a:t>
+            </a:r>
+            <a:endParaRPr lang="en-US" dirty="0"/>
+          </a:p>
+        </p:txBody>
+      </p:sp>
+      <p:sp>
+        <p:nvSpPr>
+          <p:cNvPr id="4" name="Slide Number Placeholder 3"/>
+          <p:cNvSpPr>
+            <a:spLocks noGrp="1"/>
+          </p:cNvSpPr>
+          <p:nvPr>
+            <p:ph type="sldNum" sz="quarter" idx="10"/>
+          </p:nvPr>
+        </p:nvSpPr>
+        <p:spPr/>
+        <p:txBody>
+          <a:bodyPr/>
+          <a:lstStyle/>
+          <a:p>
+            <a:fld id="{F7021451-1387-4CA6-816F-3879F97B5CBC}" type="slidenum">
+              <a:rPr lang="en-US"/>
+              <a:t>3</a:t>
+            </a:fld>
+            <a:endParaRPr lang="en-US"/>
+          </a:p>
+        </p:txBody>
+      </p:sp>
+    </p:spTree>
+    <p:extLst>
+      <p:ext uri="{BB962C8B-B14F-4D97-AF65-F5344CB8AC3E}">
+        <p14:creationId xmlns:p14="http://schemas.microsoft.com/office/powerpoint/2010/main" val="1024086991"/>
+      </p:ext>
+    </p:extLst>
+  </p:cSld>
+  <p:clrMapOvr>
+    <a:masterClrMapping/>
+  </p:clrMapOvr>
+</p:notes>
+</file>
+
+<file path=ppt/notesSlides/notesSlide4.xml><?xml version="1.0" encoding="utf-8"?>
+<p:notes xmlns:a="http://schemas.openxmlformats.org/drawingml/2006/main" xmlns:r="http://schemas.openxmlformats.org/officeDocument/2006/relationships" xmlns:p="http://schemas.openxmlformats.org/presentationml/2006/main">
+  <p:cSld>
+    <p:spTree>
+      <p:nvGrpSpPr>
+        <p:cNvPr id="1" name=""/>
+        <p:cNvGrpSpPr/>
+        <p:nvPr/>
+      </p:nvGrpSpPr>
+      <p:grpSpPr>
+        <a:xfrm>
+          <a:off x="0" y="0"/>
+          <a:ext cx="0" cy="0"/>
+          <a:chOff x="0" y="0"/>
+          <a:chExt cx="0" cy="0"/>
+        </a:xfrm>
+      </p:grpSpPr>
+      <p:sp>
+        <p:nvSpPr>
+          <p:cNvPr id="2" name="Slide Image Placeholder 1"/>
+          <p:cNvSpPr>
+            <a:spLocks noGrp="1" noRot="1" noChangeAspect="1"/>
+          </p:cNvSpPr>
+          <p:nvPr>
+            <p:ph type="sldImg"/>
+          </p:nvPr>
+        </p:nvSpPr>
+        <p:spPr/>
+      </p:sp>
+      <p:sp>
+        <p:nvSpPr>
+          <p:cNvPr id="3" name="Notes Placeholder 2"/>
+          <p:cNvSpPr>
+            <a:spLocks noGrp="1"/>
+          </p:cNvSpPr>
+          <p:nvPr>
+            <p:ph type="body" idx="1"/>
+          </p:nvPr>
+        </p:nvSpPr>
+        <p:spPr/>
+        <p:txBody>
+          <a:bodyPr/>
+          <a:lstStyle/>
+          <a:p>
+            <a:r>
+              <a:rPr lang="en-US" dirty="0"/>
+              <a:t>تحليل المديونيات — جميع القيم بالمليون ريال.</a:t>
+            </a:r>
+            <a:endParaRPr lang="en-US" dirty="0"/>
+          </a:p>
+        </p:txBody>
+      </p:sp>
+      <p:sp>
+        <p:nvSpPr>
+          <p:cNvPr id="4" name="Slide Number Placeholder 3"/>
+          <p:cNvSpPr>
+            <a:spLocks noGrp="1"/>
+          </p:cNvSpPr>
+          <p:nvPr>
+            <p:ph type="sldNum" sz="quarter" idx="10"/>
+          </p:nvPr>
+        </p:nvSpPr>
+        <p:spPr/>
+        <p:txBody>
+          <a:bodyPr/>
+          <a:lstStyle/>
+          <a:p>
+            <a:fld id="{F7021451-1387-4CA6-816F-3879F97B5CBC}" type="slidenum">
+              <a:rPr lang="en-US"/>
+              <a:t>4</a:t>
             </a:fld>
             <a:endParaRPr lang="en-US"/>
           </a:p>
@@ -5673,6 +8287,569 @@
                   <a:schemeClr val="accent1"/>
                 </a:solidFill>
               </a:rPr>
+              <a:t>تحليل مستهدفات الإيرادات</a:t>
+            </a:r>
+            <a:endParaRPr lang="en-US" sz="3000" dirty="0"/>
+          </a:p>
+        </p:txBody>
+      </p:sp>
+      <p:sp>
+        <p:nvSpPr>
+          <p:cNvPr id="3" name="chart-billed"/>
+          <p:cNvSpPr/>
+          <p:nvPr/>
+        </p:nvSpPr>
+        <p:spPr>
+          <a:xfrm>
+            <a:off x="6208776" y="1051560"/>
+            <a:ext cx="5522976" cy="2651760"/>
+          </a:xfrm>
+          <a:prstGeom prst="roundRect">
+            <a:avLst>
+              <a:gd name="adj" fmla="val 4828"/>
+            </a:avLst>
+          </a:prstGeom>
+          <a:solidFill>
+            <a:srgbClr val="FFFFFF"/>
+          </a:solidFill>
+          <a:ln/>
+          <a:effectLst>
+            <a:outerShdw sx="100000" sy="100000" kx="0" ky="0" algn="bl" rotWithShape="0" blurRad="127000" dist="25400" dir="5400000">
+              <a:srgbClr val="1E2B2A">
+                <a:alpha val="10000"/>
+              </a:srgbClr>
+            </a:outerShdw>
+          </a:effectLst>
+        </p:spPr>
+      </p:sp>
+      <p:sp>
+        <p:nvSpPr>
+          <p:cNvPr id="4" name="Shape 2"/>
+          <p:cNvSpPr/>
+          <p:nvPr/>
+        </p:nvSpPr>
+        <p:spPr>
+          <a:xfrm>
+            <a:off x="11119104" y="1216152"/>
+            <a:ext cx="384048" cy="384048"/>
+          </a:xfrm>
+          <a:prstGeom prst="ellipse">
+            <a:avLst/>
+          </a:prstGeom>
+          <a:solidFill>
+            <a:srgbClr val="2D6A66"/>
+          </a:solidFill>
+          <a:ln/>
+        </p:spPr>
+      </p:sp>
+      <p:pic>
+        <p:nvPicPr>
+          <p:cNvPr id="5" name="Image 0" descr="preencoded.png">    </p:cNvPr>
+          <p:cNvPicPr>
+            <a:picLocks noChangeAspect="1"/>
+          </p:cNvPicPr>
+          <p:nvPr/>
+        </p:nvPicPr>
+        <p:blipFill>
+          <a:blip r:embed="rId1"/>
+          <a:stretch>
+            <a:fillRect/>
+          </a:stretch>
+        </p:blipFill>
+        <p:spPr>
+          <a:xfrm>
+            <a:off x="11222797" y="1319845"/>
+            <a:ext cx="176662" cy="176662"/>
+          </a:xfrm>
+          <a:prstGeom prst="rect">
+            <a:avLst/>
+          </a:prstGeom>
+        </p:spPr>
+      </p:pic>
+      <p:sp>
+        <p:nvSpPr>
+          <p:cNvPr id="6" name="Text 3"/>
+          <p:cNvSpPr txBox="1"/>
+          <p:nvPr/>
+        </p:nvSpPr>
+        <p:spPr>
+          <a:xfrm>
+            <a:off x="6400800" y="1216152"/>
+            <a:ext cx="4608576" cy="384048"/>
+          </a:xfrm>
+          <a:prstGeom prst="rect">
+            <a:avLst/>
+          </a:prstGeom>
+          <a:noFill/>
+          <a:ln/>
+        </p:spPr>
+        <p:txBody>
+          <a:bodyPr wrap="square" lIns="0" tIns="0" rIns="0" bIns="0" rtlCol="0" anchor="ctr"/>
+          <a:lstStyle/>
+          <a:p>
+            <a:pPr rtl="1" algn="r" indent="0" marL="0">
+              <a:buNone/>
+            </a:pPr>
+            <a:r>
+              <a:rPr lang="en-US" sz="1500" b="1" dirty="0">
+                <a:solidFill>
+                  <a:srgbClr val="2D6A66"/>
+                </a:solidFill>
+              </a:rPr>
+              <a:t>الإيرادات المفوترة مقابل المستهدف</a:t>
+            </a:r>
+            <a:endParaRPr lang="en-US" sz="1500" dirty="0"/>
+          </a:p>
+        </p:txBody>
+      </p:sp>
+      <p:graphicFrame>
+        <p:nvGraphicFramePr>
+          <p:cNvPr id="7" name="Chart 0" descr=""/>
+          <p:cNvGraphicFramePr/>
+          <p:nvPr/>
+        </p:nvGraphicFramePr>
+        <p:xfrm>
+          <a:off x="6391656" y="1673352"/>
+          <a:ext cx="5157216" cy="1920240"/>
+        </p:xfrm>
+        <a:graphic xmlns:a="http://schemas.openxmlformats.org/drawingml/2006/main">
+          <a:graphicData uri="http://schemas.openxmlformats.org/drawingml/2006/chart">
+            <c:chart xmlns:c="http://schemas.openxmlformats.org/drawingml/2006/chart" r:id="rId2"/>
+          </a:graphicData>
+        </a:graphic>
+      </p:graphicFrame>
+      <p:sp>
+        <p:nvSpPr>
+          <p:cNvPr id="8" name="chart-collected"/>
+          <p:cNvSpPr/>
+          <p:nvPr/>
+        </p:nvSpPr>
+        <p:spPr>
+          <a:xfrm>
+            <a:off x="457200" y="1051560"/>
+            <a:ext cx="5522976" cy="2651760"/>
+          </a:xfrm>
+          <a:prstGeom prst="roundRect">
+            <a:avLst>
+              <a:gd name="adj" fmla="val 4828"/>
+            </a:avLst>
+          </a:prstGeom>
+          <a:solidFill>
+            <a:srgbClr val="FFFFFF"/>
+          </a:solidFill>
+          <a:ln/>
+          <a:effectLst>
+            <a:outerShdw sx="100000" sy="100000" kx="0" ky="0" algn="bl" rotWithShape="0" blurRad="127000" dist="25400" dir="5400000">
+              <a:srgbClr val="1E2B2A">
+                <a:alpha val="10000"/>
+              </a:srgbClr>
+            </a:outerShdw>
+          </a:effectLst>
+        </p:spPr>
+      </p:sp>
+      <p:sp>
+        <p:nvSpPr>
+          <p:cNvPr id="9" name="Shape 5"/>
+          <p:cNvSpPr/>
+          <p:nvPr/>
+        </p:nvSpPr>
+        <p:spPr>
+          <a:xfrm>
+            <a:off x="5367528" y="1216152"/>
+            <a:ext cx="384048" cy="384048"/>
+          </a:xfrm>
+          <a:prstGeom prst="ellipse">
+            <a:avLst/>
+          </a:prstGeom>
+          <a:solidFill>
+            <a:srgbClr val="2D6A66"/>
+          </a:solidFill>
+          <a:ln/>
+        </p:spPr>
+      </p:sp>
+      <p:pic>
+        <p:nvPicPr>
+          <p:cNvPr id="10" name="Image 1" descr="preencoded.png">    </p:cNvPr>
+          <p:cNvPicPr>
+            <a:picLocks noChangeAspect="1"/>
+          </p:cNvPicPr>
+          <p:nvPr/>
+        </p:nvPicPr>
+        <p:blipFill>
+          <a:blip r:embed="rId3"/>
+          <a:stretch>
+            <a:fillRect/>
+          </a:stretch>
+        </p:blipFill>
+        <p:spPr>
+          <a:xfrm>
+            <a:off x="5471221" y="1319845"/>
+            <a:ext cx="176662" cy="176662"/>
+          </a:xfrm>
+          <a:prstGeom prst="rect">
+            <a:avLst/>
+          </a:prstGeom>
+        </p:spPr>
+      </p:pic>
+      <p:sp>
+        <p:nvSpPr>
+          <p:cNvPr id="11" name="Text 6"/>
+          <p:cNvSpPr txBox="1"/>
+          <p:nvPr/>
+        </p:nvSpPr>
+        <p:spPr>
+          <a:xfrm>
+            <a:off x="649224" y="1216152"/>
+            <a:ext cx="4608576" cy="384048"/>
+          </a:xfrm>
+          <a:prstGeom prst="rect">
+            <a:avLst/>
+          </a:prstGeom>
+          <a:noFill/>
+          <a:ln/>
+        </p:spPr>
+        <p:txBody>
+          <a:bodyPr wrap="square" lIns="0" tIns="0" rIns="0" bIns="0" rtlCol="0" anchor="ctr"/>
+          <a:lstStyle/>
+          <a:p>
+            <a:pPr rtl="1" algn="r" indent="0" marL="0">
+              <a:buNone/>
+            </a:pPr>
+            <a:r>
+              <a:rPr lang="en-US" sz="1500" b="1" dirty="0">
+                <a:solidFill>
+                  <a:srgbClr val="2D6A66"/>
+                </a:solidFill>
+              </a:rPr>
+              <a:t>إجمالي المحصل</a:t>
+            </a:r>
+            <a:endParaRPr lang="en-US" sz="1500" dirty="0"/>
+          </a:p>
+        </p:txBody>
+      </p:sp>
+      <p:graphicFrame>
+        <p:nvGraphicFramePr>
+          <p:cNvPr id="12" name="Chart 1" descr=""/>
+          <p:cNvGraphicFramePr/>
+          <p:nvPr/>
+        </p:nvGraphicFramePr>
+        <p:xfrm>
+          <a:off x="640080" y="1673352"/>
+          <a:ext cx="5157216" cy="1920240"/>
+        </p:xfrm>
+        <a:graphic xmlns:a="http://schemas.openxmlformats.org/drawingml/2006/main">
+          <a:graphicData uri="http://schemas.openxmlformats.org/drawingml/2006/chart">
+            <c:chart xmlns:c="http://schemas.openxmlformats.org/drawingml/2006/chart" r:id="rId4"/>
+          </a:graphicData>
+        </a:graphic>
+      </p:graphicFrame>
+      <p:sp>
+        <p:nvSpPr>
+          <p:cNvPr id="13" name="chart-coverage"/>
+          <p:cNvSpPr/>
+          <p:nvPr/>
+        </p:nvSpPr>
+        <p:spPr>
+          <a:xfrm>
+            <a:off x="6208776" y="3886200"/>
+            <a:ext cx="5522976" cy="2715768"/>
+          </a:xfrm>
+          <a:prstGeom prst="roundRect">
+            <a:avLst>
+              <a:gd name="adj" fmla="val 4714"/>
+            </a:avLst>
+          </a:prstGeom>
+          <a:solidFill>
+            <a:srgbClr val="FFFFFF"/>
+          </a:solidFill>
+          <a:ln/>
+          <a:effectLst>
+            <a:outerShdw sx="100000" sy="100000" kx="0" ky="0" algn="bl" rotWithShape="0" blurRad="127000" dist="25400" dir="5400000">
+              <a:srgbClr val="1E2B2A">
+                <a:alpha val="10000"/>
+              </a:srgbClr>
+            </a:outerShdw>
+          </a:effectLst>
+        </p:spPr>
+      </p:sp>
+      <p:sp>
+        <p:nvSpPr>
+          <p:cNvPr id="14" name="Shape 8"/>
+          <p:cNvSpPr/>
+          <p:nvPr/>
+        </p:nvSpPr>
+        <p:spPr>
+          <a:xfrm>
+            <a:off x="11119104" y="4050792"/>
+            <a:ext cx="384048" cy="384048"/>
+          </a:xfrm>
+          <a:prstGeom prst="ellipse">
+            <a:avLst/>
+          </a:prstGeom>
+          <a:solidFill>
+            <a:srgbClr val="2D6A66"/>
+          </a:solidFill>
+          <a:ln/>
+        </p:spPr>
+      </p:sp>
+      <p:pic>
+        <p:nvPicPr>
+          <p:cNvPr id="15" name="Image 2" descr="preencoded.png">    </p:cNvPr>
+          <p:cNvPicPr>
+            <a:picLocks noChangeAspect="1"/>
+          </p:cNvPicPr>
+          <p:nvPr/>
+        </p:nvPicPr>
+        <p:blipFill>
+          <a:blip r:embed="rId5"/>
+          <a:stretch>
+            <a:fillRect/>
+          </a:stretch>
+        </p:blipFill>
+        <p:spPr>
+          <a:xfrm>
+            <a:off x="11222797" y="4154485"/>
+            <a:ext cx="176662" cy="176662"/>
+          </a:xfrm>
+          <a:prstGeom prst="rect">
+            <a:avLst/>
+          </a:prstGeom>
+        </p:spPr>
+      </p:pic>
+      <p:sp>
+        <p:nvSpPr>
+          <p:cNvPr id="16" name="Text 9"/>
+          <p:cNvSpPr txBox="1"/>
+          <p:nvPr/>
+        </p:nvSpPr>
+        <p:spPr>
+          <a:xfrm>
+            <a:off x="6400800" y="4050792"/>
+            <a:ext cx="4608576" cy="384048"/>
+          </a:xfrm>
+          <a:prstGeom prst="rect">
+            <a:avLst/>
+          </a:prstGeom>
+          <a:noFill/>
+          <a:ln/>
+        </p:spPr>
+        <p:txBody>
+          <a:bodyPr wrap="square" lIns="0" tIns="0" rIns="0" bIns="0" rtlCol="0" anchor="ctr"/>
+          <a:lstStyle/>
+          <a:p>
+            <a:pPr rtl="1" algn="r" indent="0" marL="0">
+              <a:buNone/>
+            </a:pPr>
+            <a:r>
+              <a:rPr lang="en-US" sz="1500" b="1" dirty="0">
+                <a:solidFill>
+                  <a:srgbClr val="2D6A66"/>
+                </a:solidFill>
+              </a:rPr>
+              <a:t>نسبة تغطية النفقات التشغيلية</a:t>
+            </a:r>
+            <a:endParaRPr lang="en-US" sz="1500" dirty="0"/>
+          </a:p>
+        </p:txBody>
+      </p:sp>
+      <p:graphicFrame>
+        <p:nvGraphicFramePr>
+          <p:cNvPr id="17" name="Chart 2" descr=""/>
+          <p:cNvGraphicFramePr/>
+          <p:nvPr/>
+        </p:nvGraphicFramePr>
+        <p:xfrm>
+          <a:off x="6391656" y="4507992"/>
+          <a:ext cx="5157216" cy="1984248"/>
+        </p:xfrm>
+        <a:graphic xmlns:a="http://schemas.openxmlformats.org/drawingml/2006/main">
+          <a:graphicData uri="http://schemas.openxmlformats.org/drawingml/2006/chart">
+            <c:chart xmlns:c="http://schemas.openxmlformats.org/drawingml/2006/chart" r:id="rId6"/>
+          </a:graphicData>
+        </a:graphic>
+      </p:graphicFrame>
+      <p:sp>
+        <p:nvSpPr>
+          <p:cNvPr id="18" name="chart-opex-targets"/>
+          <p:cNvSpPr/>
+          <p:nvPr/>
+        </p:nvSpPr>
+        <p:spPr>
+          <a:xfrm>
+            <a:off x="457200" y="3886200"/>
+            <a:ext cx="5522976" cy="2715768"/>
+          </a:xfrm>
+          <a:prstGeom prst="roundRect">
+            <a:avLst>
+              <a:gd name="adj" fmla="val 4714"/>
+            </a:avLst>
+          </a:prstGeom>
+          <a:solidFill>
+            <a:srgbClr val="FFFFFF"/>
+          </a:solidFill>
+          <a:ln/>
+          <a:effectLst>
+            <a:outerShdw sx="100000" sy="100000" kx="0" ky="0" algn="bl" rotWithShape="0" blurRad="127000" dist="25400" dir="5400000">
+              <a:srgbClr val="1E2B2A">
+                <a:alpha val="10000"/>
+              </a:srgbClr>
+            </a:outerShdw>
+          </a:effectLst>
+        </p:spPr>
+      </p:sp>
+      <p:sp>
+        <p:nvSpPr>
+          <p:cNvPr id="19" name="Shape 11"/>
+          <p:cNvSpPr/>
+          <p:nvPr/>
+        </p:nvSpPr>
+        <p:spPr>
+          <a:xfrm>
+            <a:off x="5367528" y="4050792"/>
+            <a:ext cx="384048" cy="384048"/>
+          </a:xfrm>
+          <a:prstGeom prst="ellipse">
+            <a:avLst/>
+          </a:prstGeom>
+          <a:solidFill>
+            <a:srgbClr val="2D6A66"/>
+          </a:solidFill>
+          <a:ln/>
+        </p:spPr>
+      </p:sp>
+      <p:pic>
+        <p:nvPicPr>
+          <p:cNvPr id="20" name="Image 3" descr="preencoded.png">    </p:cNvPr>
+          <p:cNvPicPr>
+            <a:picLocks noChangeAspect="1"/>
+          </p:cNvPicPr>
+          <p:nvPr/>
+        </p:nvPicPr>
+        <p:blipFill>
+          <a:blip r:embed="rId7"/>
+          <a:stretch>
+            <a:fillRect/>
+          </a:stretch>
+        </p:blipFill>
+        <p:spPr>
+          <a:xfrm>
+            <a:off x="5471221" y="4154485"/>
+            <a:ext cx="176662" cy="176662"/>
+          </a:xfrm>
+          <a:prstGeom prst="rect">
+            <a:avLst/>
+          </a:prstGeom>
+        </p:spPr>
+      </p:pic>
+      <p:sp>
+        <p:nvSpPr>
+          <p:cNvPr id="21" name="Text 12"/>
+          <p:cNvSpPr txBox="1"/>
+          <p:nvPr/>
+        </p:nvSpPr>
+        <p:spPr>
+          <a:xfrm>
+            <a:off x="649224" y="4050792"/>
+            <a:ext cx="4608576" cy="384048"/>
+          </a:xfrm>
+          <a:prstGeom prst="rect">
+            <a:avLst/>
+          </a:prstGeom>
+          <a:noFill/>
+          <a:ln/>
+        </p:spPr>
+        <p:txBody>
+          <a:bodyPr wrap="square" lIns="0" tIns="0" rIns="0" bIns="0" rtlCol="0" anchor="ctr"/>
+          <a:lstStyle/>
+          <a:p>
+            <a:pPr rtl="1" algn="r" indent="0" marL="0">
+              <a:buNone/>
+            </a:pPr>
+            <a:r>
+              <a:rPr lang="en-US" sz="1500" b="1" dirty="0">
+                <a:solidFill>
+                  <a:srgbClr val="2D6A66"/>
+                </a:solidFill>
+              </a:rPr>
+              <a:t>القيمة مقابل مستهدف النفقات التشغيلية</a:t>
+            </a:r>
+            <a:endParaRPr lang="en-US" sz="1500" dirty="0"/>
+          </a:p>
+        </p:txBody>
+      </p:sp>
+      <p:graphicFrame>
+        <p:nvGraphicFramePr>
+          <p:cNvPr id="22" name="Chart 3" descr=""/>
+          <p:cNvGraphicFramePr/>
+          <p:nvPr/>
+        </p:nvGraphicFramePr>
+        <p:xfrm>
+          <a:off x="640080" y="4507992"/>
+          <a:ext cx="5157216" cy="1984248"/>
+        </p:xfrm>
+        <a:graphic xmlns:a="http://schemas.openxmlformats.org/drawingml/2006/main">
+          <a:graphicData uri="http://schemas.openxmlformats.org/drawingml/2006/chart">
+            <c:chart xmlns:c="http://schemas.openxmlformats.org/drawingml/2006/chart" r:id="rId8"/>
+          </a:graphicData>
+        </a:graphic>
+      </p:graphicFrame>
+    </p:spTree>
+  </p:cSld>
+  <p:clrMapOvr>
+    <a:masterClrMapping/>
+  </p:clrMapOvr>
+</p:sld>
+</file>
+
+<file path=ppt/slides/slide3.xml><?xml version="1.0" encoding="utf-8"?>
+<p:sld xmlns:a="http://schemas.openxmlformats.org/drawingml/2006/main" xmlns:r="http://schemas.openxmlformats.org/officeDocument/2006/relationships" xmlns:p="http://schemas.openxmlformats.org/presentationml/2006/main">
+  <p:cSld name="Slide 3">
+    <p:spTree>
+      <p:nvGrpSpPr>
+        <p:cNvPr id="1" name=""/>
+        <p:cNvGrpSpPr/>
+        <p:nvPr/>
+      </p:nvGrpSpPr>
+      <p:grpSpPr>
+        <a:xfrm>
+          <a:off x="0" y="0"/>
+          <a:ext cx="0" cy="0"/>
+          <a:chOff x="0" y="0"/>
+          <a:chExt cx="0" cy="0"/>
+        </a:xfrm>
+      </p:grpSpPr>
+      <p:sp>
+        <p:nvSpPr>
+          <p:cNvPr id="2" name="Text 1"/>
+          <p:cNvSpPr/>
+          <p:nvPr>
+            <p:ph idx="102" type="title" hasCustomPrompt="1"/>
+          </p:nvPr>
+        </p:nvSpPr>
+        <p:spPr>
+          <a:xfrm>
+            <a:off x="5486400" y="274320"/>
+            <a:ext cx="6245352" cy="603504"/>
+          </a:xfrm>
+          <a:prstGeom prst="rect">
+            <a:avLst/>
+          </a:prstGeom>
+          <a:noFill/>
+          <a:ln/>
+        </p:spPr>
+        <p:txBody>
+          <a:bodyPr wrap="square" lIns="0" tIns="0" rIns="0" bIns="0" rtlCol="0" anchor="ctr"/>
+          <a:lstStyle/>
+          <a:p>
+            <a:pPr rtl="1" algn="r" indent="0" marL="0">
+              <a:buNone/>
+            </a:pPr>
+            <a:r>
+              <a:rPr lang="en-US" sz="3000" b="1" dirty="0">
+                <a:solidFill>
+                  <a:schemeClr val="accent1"/>
+                </a:solidFill>
+              </a:rPr>
               <a:t>حالة المديونيات</a:t>
             </a:r>
             <a:endParaRPr lang="en-US" sz="3000" dirty="0"/>
@@ -7513,6 +10690,815 @@
         <a:graphic xmlns:a="http://schemas.openxmlformats.org/drawingml/2006/main">
           <a:graphicData uri="http://schemas.openxmlformats.org/drawingml/2006/chart">
             <c:chart xmlns:c="http://schemas.openxmlformats.org/drawingml/2006/chart" r:id="rId7"/>
+          </a:graphicData>
+        </a:graphic>
+      </p:graphicFrame>
+    </p:spTree>
+  </p:cSld>
+  <p:clrMapOvr>
+    <a:masterClrMapping/>
+  </p:clrMapOvr>
+</p:sld>
+</file>
+
+<file path=ppt/slides/slide4.xml><?xml version="1.0" encoding="utf-8"?>
+<p:sld xmlns:a="http://schemas.openxmlformats.org/drawingml/2006/main" xmlns:r="http://schemas.openxmlformats.org/officeDocument/2006/relationships" xmlns:p="http://schemas.openxmlformats.org/presentationml/2006/main">
+  <p:cSld name="Slide 4">
+    <p:spTree>
+      <p:nvGrpSpPr>
+        <p:cNvPr id="1" name=""/>
+        <p:cNvGrpSpPr/>
+        <p:nvPr/>
+      </p:nvGrpSpPr>
+      <p:grpSpPr>
+        <a:xfrm>
+          <a:off x="0" y="0"/>
+          <a:ext cx="0" cy="0"/>
+          <a:chOff x="0" y="0"/>
+          <a:chExt cx="0" cy="0"/>
+        </a:xfrm>
+      </p:grpSpPr>
+      <p:sp>
+        <p:nvSpPr>
+          <p:cNvPr id="2" name="Text 1"/>
+          <p:cNvSpPr/>
+          <p:nvPr>
+            <p:ph idx="102" type="title" hasCustomPrompt="1"/>
+          </p:nvPr>
+        </p:nvSpPr>
+        <p:spPr>
+          <a:xfrm>
+            <a:off x="5486400" y="274320"/>
+            <a:ext cx="6245352" cy="603504"/>
+          </a:xfrm>
+          <a:prstGeom prst="rect">
+            <a:avLst/>
+          </a:prstGeom>
+          <a:noFill/>
+          <a:ln/>
+        </p:spPr>
+        <p:txBody>
+          <a:bodyPr wrap="square" lIns="0" tIns="0" rIns="0" bIns="0" rtlCol="0" anchor="ctr"/>
+          <a:lstStyle/>
+          <a:p>
+            <a:pPr rtl="1" algn="r" indent="0" marL="0">
+              <a:buNone/>
+            </a:pPr>
+            <a:r>
+              <a:rPr lang="en-US" sz="3000" b="1" dirty="0">
+                <a:solidFill>
+                  <a:schemeClr val="accent1"/>
+                </a:solidFill>
+              </a:rPr>
+              <a:t>تحليل المديونيات</a:t>
+            </a:r>
+            <a:endParaRPr lang="en-US" sz="3000" dirty="0"/>
+          </a:p>
+        </p:txBody>
+      </p:sp>
+      <p:sp>
+        <p:nvSpPr>
+          <p:cNvPr id="3" name="chart-debt-flow"/>
+          <p:cNvSpPr/>
+          <p:nvPr/>
+        </p:nvSpPr>
+        <p:spPr>
+          <a:xfrm>
+            <a:off x="6208776" y="1051560"/>
+            <a:ext cx="5522976" cy="2651760"/>
+          </a:xfrm>
+          <a:prstGeom prst="roundRect">
+            <a:avLst>
+              <a:gd name="adj" fmla="val 4828"/>
+            </a:avLst>
+          </a:prstGeom>
+          <a:solidFill>
+            <a:srgbClr val="FFFFFF"/>
+          </a:solidFill>
+          <a:ln/>
+          <a:effectLst>
+            <a:outerShdw sx="100000" sy="100000" kx="0" ky="0" algn="bl" rotWithShape="0" blurRad="127000" dist="25400" dir="5400000">
+              <a:srgbClr val="1E2B2A">
+                <a:alpha val="10000"/>
+              </a:srgbClr>
+            </a:outerShdw>
+          </a:effectLst>
+        </p:spPr>
+      </p:sp>
+      <p:sp>
+        <p:nvSpPr>
+          <p:cNvPr id="4" name="Shape 2"/>
+          <p:cNvSpPr/>
+          <p:nvPr/>
+        </p:nvSpPr>
+        <p:spPr>
+          <a:xfrm>
+            <a:off x="11119104" y="1216152"/>
+            <a:ext cx="384048" cy="384048"/>
+          </a:xfrm>
+          <a:prstGeom prst="ellipse">
+            <a:avLst/>
+          </a:prstGeom>
+          <a:solidFill>
+            <a:srgbClr val="2D6A66"/>
+          </a:solidFill>
+          <a:ln/>
+        </p:spPr>
+      </p:sp>
+      <p:pic>
+        <p:nvPicPr>
+          <p:cNvPr id="5" name="Image 0" descr="preencoded.png">    </p:cNvPr>
+          <p:cNvPicPr>
+            <a:picLocks noChangeAspect="1"/>
+          </p:cNvPicPr>
+          <p:nvPr/>
+        </p:nvPicPr>
+        <p:blipFill>
+          <a:blip r:embed="rId1"/>
+          <a:stretch>
+            <a:fillRect/>
+          </a:stretch>
+        </p:blipFill>
+        <p:spPr>
+          <a:xfrm>
+            <a:off x="11222797" y="1319845"/>
+            <a:ext cx="176662" cy="176662"/>
+          </a:xfrm>
+          <a:prstGeom prst="rect">
+            <a:avLst/>
+          </a:prstGeom>
+        </p:spPr>
+      </p:pic>
+      <p:sp>
+        <p:nvSpPr>
+          <p:cNvPr id="6" name="Text 3"/>
+          <p:cNvSpPr txBox="1"/>
+          <p:nvPr/>
+        </p:nvSpPr>
+        <p:spPr>
+          <a:xfrm>
+            <a:off x="6400800" y="1216152"/>
+            <a:ext cx="4608576" cy="384048"/>
+          </a:xfrm>
+          <a:prstGeom prst="rect">
+            <a:avLst/>
+          </a:prstGeom>
+          <a:noFill/>
+          <a:ln/>
+        </p:spPr>
+        <p:txBody>
+          <a:bodyPr wrap="square" lIns="0" tIns="0" rIns="0" bIns="0" rtlCol="0" anchor="ctr"/>
+          <a:lstStyle/>
+          <a:p>
+            <a:pPr rtl="1" algn="r" indent="0" marL="0">
+              <a:buNone/>
+            </a:pPr>
+            <a:r>
+              <a:rPr lang="en-US" sz="1500" b="1" dirty="0">
+                <a:solidFill>
+                  <a:srgbClr val="2D6A66"/>
+                </a:solidFill>
+              </a:rPr>
+              <a:t>حركة المديونية في السنة الحالية</a:t>
+            </a:r>
+            <a:endParaRPr lang="en-US" sz="1500" dirty="0"/>
+          </a:p>
+        </p:txBody>
+      </p:sp>
+      <p:graphicFrame>
+        <p:nvGraphicFramePr>
+          <p:cNvPr id="7" name="Chart 0" descr=""/>
+          <p:cNvGraphicFramePr/>
+          <p:nvPr/>
+        </p:nvGraphicFramePr>
+        <p:xfrm>
+          <a:off x="6391656" y="1673352"/>
+          <a:ext cx="5157216" cy="1920240"/>
+        </p:xfrm>
+        <a:graphic xmlns:a="http://schemas.openxmlformats.org/drawingml/2006/main">
+          <a:graphicData uri="http://schemas.openxmlformats.org/drawingml/2006/chart">
+            <c:chart xmlns:c="http://schemas.openxmlformats.org/drawingml/2006/chart" r:id="rId2"/>
+          </a:graphicData>
+        </a:graphic>
+      </p:graphicFrame>
+      <p:sp>
+        <p:nvSpPr>
+          <p:cNvPr id="8" name="chart-pay-ratio"/>
+          <p:cNvSpPr/>
+          <p:nvPr/>
+        </p:nvSpPr>
+        <p:spPr>
+          <a:xfrm>
+            <a:off x="457200" y="1051560"/>
+            <a:ext cx="5522976" cy="2651760"/>
+          </a:xfrm>
+          <a:prstGeom prst="roundRect">
+            <a:avLst>
+              <a:gd name="adj" fmla="val 4828"/>
+            </a:avLst>
+          </a:prstGeom>
+          <a:solidFill>
+            <a:srgbClr val="FFFFFF"/>
+          </a:solidFill>
+          <a:ln/>
+          <a:effectLst>
+            <a:outerShdw sx="100000" sy="100000" kx="0" ky="0" algn="bl" rotWithShape="0" blurRad="127000" dist="25400" dir="5400000">
+              <a:srgbClr val="1E2B2A">
+                <a:alpha val="10000"/>
+              </a:srgbClr>
+            </a:outerShdw>
+          </a:effectLst>
+        </p:spPr>
+      </p:sp>
+      <p:sp>
+        <p:nvSpPr>
+          <p:cNvPr id="9" name="Shape 5"/>
+          <p:cNvSpPr/>
+          <p:nvPr/>
+        </p:nvSpPr>
+        <p:spPr>
+          <a:xfrm>
+            <a:off x="5367528" y="1216152"/>
+            <a:ext cx="384048" cy="384048"/>
+          </a:xfrm>
+          <a:prstGeom prst="ellipse">
+            <a:avLst/>
+          </a:prstGeom>
+          <a:solidFill>
+            <a:srgbClr val="2D6A66"/>
+          </a:solidFill>
+          <a:ln/>
+        </p:spPr>
+      </p:sp>
+      <p:pic>
+        <p:nvPicPr>
+          <p:cNvPr id="10" name="Image 1" descr="preencoded.png">    </p:cNvPr>
+          <p:cNvPicPr>
+            <a:picLocks noChangeAspect="1"/>
+          </p:cNvPicPr>
+          <p:nvPr/>
+        </p:nvPicPr>
+        <p:blipFill>
+          <a:blip r:embed="rId3"/>
+          <a:stretch>
+            <a:fillRect/>
+          </a:stretch>
+        </p:blipFill>
+        <p:spPr>
+          <a:xfrm>
+            <a:off x="5471221" y="1319845"/>
+            <a:ext cx="176662" cy="176662"/>
+          </a:xfrm>
+          <a:prstGeom prst="rect">
+            <a:avLst/>
+          </a:prstGeom>
+        </p:spPr>
+      </p:pic>
+      <p:sp>
+        <p:nvSpPr>
+          <p:cNvPr id="11" name="Text 6"/>
+          <p:cNvSpPr txBox="1"/>
+          <p:nvPr/>
+        </p:nvSpPr>
+        <p:spPr>
+          <a:xfrm>
+            <a:off x="649224" y="1216152"/>
+            <a:ext cx="4608576" cy="384048"/>
+          </a:xfrm>
+          <a:prstGeom prst="rect">
+            <a:avLst/>
+          </a:prstGeom>
+          <a:noFill/>
+          <a:ln/>
+        </p:spPr>
+        <p:txBody>
+          <a:bodyPr wrap="square" lIns="0" tIns="0" rIns="0" bIns="0" rtlCol="0" anchor="ctr"/>
+          <a:lstStyle/>
+          <a:p>
+            <a:pPr rtl="1" algn="r" indent="0" marL="0">
+              <a:buNone/>
+            </a:pPr>
+            <a:r>
+              <a:rPr lang="en-US" sz="1500" b="1" dirty="0">
+                <a:solidFill>
+                  <a:srgbClr val="2D6A66"/>
+                </a:solidFill>
+              </a:rPr>
+              <a:t>نسبة السداد</a:t>
+            </a:r>
+            <a:endParaRPr lang="en-US" sz="1500" dirty="0"/>
+          </a:p>
+        </p:txBody>
+      </p:sp>
+      <p:graphicFrame>
+        <p:nvGraphicFramePr>
+          <p:cNvPr id="12" name="Chart 1" descr=""/>
+          <p:cNvGraphicFramePr/>
+          <p:nvPr/>
+        </p:nvGraphicFramePr>
+        <p:xfrm>
+          <a:off x="960120" y="1741932"/>
+          <a:ext cx="1783080" cy="1783080"/>
+        </p:xfrm>
+        <a:graphic xmlns:a="http://schemas.openxmlformats.org/drawingml/2006/main">
+          <a:graphicData uri="http://schemas.openxmlformats.org/drawingml/2006/chart">
+            <c:chart xmlns:c="http://schemas.openxmlformats.org/drawingml/2006/chart" r:id="rId4"/>
+          </a:graphicData>
+        </a:graphic>
+      </p:graphicFrame>
+      <p:sp>
+        <p:nvSpPr>
+          <p:cNvPr id="13" name="Text 7"/>
+          <p:cNvSpPr txBox="1"/>
+          <p:nvPr/>
+        </p:nvSpPr>
+        <p:spPr>
+          <a:xfrm>
+            <a:off x="960120" y="2404872"/>
+            <a:ext cx="1783080" cy="457200"/>
+          </a:xfrm>
+          <a:prstGeom prst="rect">
+            <a:avLst/>
+          </a:prstGeom>
+          <a:noFill/>
+          <a:ln/>
+        </p:spPr>
+        <p:txBody>
+          <a:bodyPr wrap="square" lIns="0" tIns="0" rIns="0" bIns="0" rtlCol="0" anchor="ctr"/>
+          <a:lstStyle/>
+          <a:p>
+            <a:pPr rtl="1" algn="ctr" indent="0" marL="0">
+              <a:buNone/>
+            </a:pPr>
+            <a:r>
+              <a:rPr lang="en-US" sz="2400" b="1" dirty="0">
+                <a:solidFill>
+                  <a:srgbClr val="2D6A66"/>
+                </a:solidFill>
+              </a:rPr>
+              <a:t>62%</a:t>
+            </a:r>
+            <a:endParaRPr lang="en-US" sz="2400" dirty="0"/>
+          </a:p>
+        </p:txBody>
+      </p:sp>
+      <p:sp>
+        <p:nvSpPr>
+          <p:cNvPr id="14" name="Shape 8"/>
+          <p:cNvSpPr/>
+          <p:nvPr/>
+        </p:nvSpPr>
+        <p:spPr>
+          <a:xfrm>
+            <a:off x="5669280" y="2011680"/>
+            <a:ext cx="128016" cy="128016"/>
+          </a:xfrm>
+          <a:prstGeom prst="roundRect">
+            <a:avLst>
+              <a:gd name="adj" fmla="val 21429"/>
+            </a:avLst>
+          </a:prstGeom>
+          <a:solidFill>
+            <a:srgbClr val="2D6A66"/>
+          </a:solidFill>
+          <a:ln/>
+        </p:spPr>
+      </p:sp>
+      <p:sp>
+        <p:nvSpPr>
+          <p:cNvPr id="15" name="Text 9"/>
+          <p:cNvSpPr txBox="1"/>
+          <p:nvPr/>
+        </p:nvSpPr>
+        <p:spPr>
+          <a:xfrm>
+            <a:off x="3108960" y="1947672"/>
+            <a:ext cx="2468880" cy="256032"/>
+          </a:xfrm>
+          <a:prstGeom prst="rect">
+            <a:avLst/>
+          </a:prstGeom>
+          <a:noFill/>
+          <a:ln/>
+        </p:spPr>
+        <p:txBody>
+          <a:bodyPr wrap="square" lIns="0" tIns="0" rIns="0" bIns="0" rtlCol="0" anchor="ctr"/>
+          <a:lstStyle/>
+          <a:p>
+            <a:pPr rtl="1" algn="r" indent="0" marL="0">
+              <a:buNone/>
+            </a:pPr>
+            <a:r>
+              <a:rPr lang="en-US" sz="1100" dirty="0">
+                <a:solidFill>
+                  <a:srgbClr val="6B7675"/>
+                </a:solidFill>
+              </a:rPr>
+              <a:t>ما تم سداده من المديونية في السنة الحالية</a:t>
+            </a:r>
+            <a:endParaRPr lang="en-US" sz="1100" dirty="0"/>
+          </a:p>
+        </p:txBody>
+      </p:sp>
+      <p:sp>
+        <p:nvSpPr>
+          <p:cNvPr id="16" name="Text 10"/>
+          <p:cNvSpPr txBox="1"/>
+          <p:nvPr/>
+        </p:nvSpPr>
+        <p:spPr>
+          <a:xfrm>
+            <a:off x="3108960" y="2240280"/>
+            <a:ext cx="2468880" cy="411480"/>
+          </a:xfrm>
+          <a:prstGeom prst="rect">
+            <a:avLst/>
+          </a:prstGeom>
+          <a:noFill/>
+          <a:ln/>
+        </p:spPr>
+        <p:txBody>
+          <a:bodyPr wrap="square" lIns="0" tIns="0" rIns="0" bIns="0" rtlCol="0" anchor="ctr"/>
+          <a:lstStyle/>
+          <a:p>
+            <a:pPr algn="r" indent="0" marL="0">
+              <a:buNone/>
+            </a:pPr>
+            <a:r>
+              <a:rPr lang="en-US" sz="2400" b="1" dirty="0">
+                <a:solidFill>
+                  <a:srgbClr val="1E2B2A"/>
+                </a:solidFill>
+              </a:rPr>
+              <a:t>328</a:t>
+            </a:r>
+            <a:pPr algn="r" indent="0" marL="0">
+              <a:buNone/>
+            </a:pPr>
+            <a:r>
+              <a:rPr lang="en-US" sz="1000" dirty="0">
+                <a:solidFill>
+                  <a:srgbClr val="6B7675"/>
+                </a:solidFill>
+              </a:rPr>
+              <a:t>  مليون ريال</a:t>
+            </a:r>
+            <a:endParaRPr lang="en-US" sz="1200" dirty="0"/>
+          </a:p>
+        </p:txBody>
+      </p:sp>
+      <p:sp>
+        <p:nvSpPr>
+          <p:cNvPr id="17" name="Shape 11"/>
+          <p:cNvSpPr/>
+          <p:nvPr/>
+        </p:nvSpPr>
+        <p:spPr>
+          <a:xfrm>
+            <a:off x="5669280" y="2926080"/>
+            <a:ext cx="128016" cy="128016"/>
+          </a:xfrm>
+          <a:prstGeom prst="roundRect">
+            <a:avLst>
+              <a:gd name="adj" fmla="val 21429"/>
+            </a:avLst>
+          </a:prstGeom>
+          <a:solidFill>
+            <a:srgbClr val="8A8F8E"/>
+          </a:solidFill>
+          <a:ln/>
+        </p:spPr>
+      </p:sp>
+      <p:sp>
+        <p:nvSpPr>
+          <p:cNvPr id="18" name="Text 12"/>
+          <p:cNvSpPr txBox="1"/>
+          <p:nvPr/>
+        </p:nvSpPr>
+        <p:spPr>
+          <a:xfrm>
+            <a:off x="3108960" y="2862072"/>
+            <a:ext cx="2468880" cy="256032"/>
+          </a:xfrm>
+          <a:prstGeom prst="rect">
+            <a:avLst/>
+          </a:prstGeom>
+          <a:noFill/>
+          <a:ln/>
+        </p:spPr>
+        <p:txBody>
+          <a:bodyPr wrap="square" lIns="0" tIns="0" rIns="0" bIns="0" rtlCol="0" anchor="ctr"/>
+          <a:lstStyle/>
+          <a:p>
+            <a:pPr rtl="1" algn="r" indent="0" marL="0">
+              <a:buNone/>
+            </a:pPr>
+            <a:r>
+              <a:rPr lang="en-US" sz="1100" dirty="0">
+                <a:solidFill>
+                  <a:srgbClr val="6B7675"/>
+                </a:solidFill>
+              </a:rPr>
+              <a:t>المتبقي من المديونية</a:t>
+            </a:r>
+            <a:endParaRPr lang="en-US" sz="1100" dirty="0"/>
+          </a:p>
+        </p:txBody>
+      </p:sp>
+      <p:sp>
+        <p:nvSpPr>
+          <p:cNvPr id="19" name="Text 13"/>
+          <p:cNvSpPr txBox="1"/>
+          <p:nvPr/>
+        </p:nvSpPr>
+        <p:spPr>
+          <a:xfrm>
+            <a:off x="3108960" y="3154680"/>
+            <a:ext cx="2468880" cy="411480"/>
+          </a:xfrm>
+          <a:prstGeom prst="rect">
+            <a:avLst/>
+          </a:prstGeom>
+          <a:noFill/>
+          <a:ln/>
+        </p:spPr>
+        <p:txBody>
+          <a:bodyPr wrap="square" lIns="0" tIns="0" rIns="0" bIns="0" rtlCol="0" anchor="ctr"/>
+          <a:lstStyle/>
+          <a:p>
+            <a:pPr algn="r" indent="0" marL="0">
+              <a:buNone/>
+            </a:pPr>
+            <a:r>
+              <a:rPr lang="en-US" sz="2400" b="1" dirty="0">
+                <a:solidFill>
+                  <a:srgbClr val="1E2B2A"/>
+                </a:solidFill>
+              </a:rPr>
+              <a:t>125</a:t>
+            </a:r>
+            <a:pPr algn="r" indent="0" marL="0">
+              <a:buNone/>
+            </a:pPr>
+            <a:r>
+              <a:rPr lang="en-US" sz="1000" dirty="0">
+                <a:solidFill>
+                  <a:srgbClr val="6B7675"/>
+                </a:solidFill>
+              </a:rPr>
+              <a:t>  مليون ريال</a:t>
+            </a:r>
+            <a:endParaRPr lang="en-US" sz="1200" dirty="0"/>
+          </a:p>
+        </p:txBody>
+      </p:sp>
+      <p:sp>
+        <p:nvSpPr>
+          <p:cNvPr id="20" name="chart-periods"/>
+          <p:cNvSpPr/>
+          <p:nvPr/>
+        </p:nvSpPr>
+        <p:spPr>
+          <a:xfrm>
+            <a:off x="6208776" y="3886200"/>
+            <a:ext cx="5522976" cy="2715768"/>
+          </a:xfrm>
+          <a:prstGeom prst="roundRect">
+            <a:avLst>
+              <a:gd name="adj" fmla="val 4714"/>
+            </a:avLst>
+          </a:prstGeom>
+          <a:solidFill>
+            <a:srgbClr val="FFFFFF"/>
+          </a:solidFill>
+          <a:ln/>
+          <a:effectLst>
+            <a:outerShdw sx="100000" sy="100000" kx="0" ky="0" algn="bl" rotWithShape="0" blurRad="127000" dist="25400" dir="5400000">
+              <a:srgbClr val="1E2B2A">
+                <a:alpha val="10000"/>
+              </a:srgbClr>
+            </a:outerShdw>
+          </a:effectLst>
+        </p:spPr>
+      </p:sp>
+      <p:sp>
+        <p:nvSpPr>
+          <p:cNvPr id="21" name="Shape 15"/>
+          <p:cNvSpPr/>
+          <p:nvPr/>
+        </p:nvSpPr>
+        <p:spPr>
+          <a:xfrm>
+            <a:off x="11119104" y="4050792"/>
+            <a:ext cx="384048" cy="384048"/>
+          </a:xfrm>
+          <a:prstGeom prst="ellipse">
+            <a:avLst/>
+          </a:prstGeom>
+          <a:solidFill>
+            <a:srgbClr val="2D6A66"/>
+          </a:solidFill>
+          <a:ln/>
+        </p:spPr>
+      </p:sp>
+      <p:pic>
+        <p:nvPicPr>
+          <p:cNvPr id="22" name="Image 2" descr="preencoded.png">    </p:cNvPr>
+          <p:cNvPicPr>
+            <a:picLocks noChangeAspect="1"/>
+          </p:cNvPicPr>
+          <p:nvPr/>
+        </p:nvPicPr>
+        <p:blipFill>
+          <a:blip r:embed="rId5"/>
+          <a:stretch>
+            <a:fillRect/>
+          </a:stretch>
+        </p:blipFill>
+        <p:spPr>
+          <a:xfrm>
+            <a:off x="11222797" y="4154485"/>
+            <a:ext cx="176662" cy="176662"/>
+          </a:xfrm>
+          <a:prstGeom prst="rect">
+            <a:avLst/>
+          </a:prstGeom>
+        </p:spPr>
+      </p:pic>
+      <p:sp>
+        <p:nvSpPr>
+          <p:cNvPr id="23" name="Text 16"/>
+          <p:cNvSpPr txBox="1"/>
+          <p:nvPr/>
+        </p:nvSpPr>
+        <p:spPr>
+          <a:xfrm>
+            <a:off x="6400800" y="4050792"/>
+            <a:ext cx="4608576" cy="384048"/>
+          </a:xfrm>
+          <a:prstGeom prst="rect">
+            <a:avLst/>
+          </a:prstGeom>
+          <a:noFill/>
+          <a:ln/>
+        </p:spPr>
+        <p:txBody>
+          <a:bodyPr wrap="square" lIns="0" tIns="0" rIns="0" bIns="0" rtlCol="0" anchor="ctr"/>
+          <a:lstStyle/>
+          <a:p>
+            <a:pPr rtl="1" algn="r" indent="0" marL="0">
+              <a:buNone/>
+            </a:pPr>
+            <a:r>
+              <a:rPr lang="en-US" sz="1500" b="1" dirty="0">
+                <a:solidFill>
+                  <a:srgbClr val="2D6A66"/>
+                </a:solidFill>
+              </a:rPr>
+              <a:t>مقارنة الفترتين</a:t>
+            </a:r>
+            <a:endParaRPr lang="en-US" sz="1500" dirty="0"/>
+          </a:p>
+        </p:txBody>
+      </p:sp>
+      <p:graphicFrame>
+        <p:nvGraphicFramePr>
+          <p:cNvPr id="24" name="Chart 2" descr=""/>
+          <p:cNvGraphicFramePr/>
+          <p:nvPr/>
+        </p:nvGraphicFramePr>
+        <p:xfrm>
+          <a:off x="6391656" y="4507992"/>
+          <a:ext cx="5157216" cy="1984248"/>
+        </p:xfrm>
+        <a:graphic xmlns:a="http://schemas.openxmlformats.org/drawingml/2006/main">
+          <a:graphicData uri="http://schemas.openxmlformats.org/drawingml/2006/chart">
+            <c:chart xmlns:c="http://schemas.openxmlformats.org/drawingml/2006/chart" r:id="rId6"/>
+          </a:graphicData>
+        </a:graphic>
+      </p:graphicFrame>
+      <p:sp>
+        <p:nvSpPr>
+          <p:cNvPr id="25" name="chart-tabs"/>
+          <p:cNvSpPr/>
+          <p:nvPr/>
+        </p:nvSpPr>
+        <p:spPr>
+          <a:xfrm>
+            <a:off x="457200" y="3886200"/>
+            <a:ext cx="5522976" cy="2715768"/>
+          </a:xfrm>
+          <a:prstGeom prst="roundRect">
+            <a:avLst>
+              <a:gd name="adj" fmla="val 4714"/>
+            </a:avLst>
+          </a:prstGeom>
+          <a:solidFill>
+            <a:srgbClr val="FFFFFF"/>
+          </a:solidFill>
+          <a:ln/>
+          <a:effectLst>
+            <a:outerShdw sx="100000" sy="100000" kx="0" ky="0" algn="bl" rotWithShape="0" blurRad="127000" dist="25400" dir="5400000">
+              <a:srgbClr val="1E2B2A">
+                <a:alpha val="10000"/>
+              </a:srgbClr>
+            </a:outerShdw>
+          </a:effectLst>
+        </p:spPr>
+      </p:sp>
+      <p:sp>
+        <p:nvSpPr>
+          <p:cNvPr id="26" name="Shape 18"/>
+          <p:cNvSpPr/>
+          <p:nvPr/>
+        </p:nvSpPr>
+        <p:spPr>
+          <a:xfrm>
+            <a:off x="5367528" y="4050792"/>
+            <a:ext cx="384048" cy="384048"/>
+          </a:xfrm>
+          <a:prstGeom prst="ellipse">
+            <a:avLst/>
+          </a:prstGeom>
+          <a:solidFill>
+            <a:srgbClr val="2D6A66"/>
+          </a:solidFill>
+          <a:ln/>
+        </p:spPr>
+      </p:sp>
+      <p:pic>
+        <p:nvPicPr>
+          <p:cNvPr id="27" name="Image 3" descr="preencoded.png">    </p:cNvPr>
+          <p:cNvPicPr>
+            <a:picLocks noChangeAspect="1"/>
+          </p:cNvPicPr>
+          <p:nvPr/>
+        </p:nvPicPr>
+        <p:blipFill>
+          <a:blip r:embed="rId7"/>
+          <a:stretch>
+            <a:fillRect/>
+          </a:stretch>
+        </p:blipFill>
+        <p:spPr>
+          <a:xfrm>
+            <a:off x="5471221" y="4154485"/>
+            <a:ext cx="176662" cy="176662"/>
+          </a:xfrm>
+          <a:prstGeom prst="rect">
+            <a:avLst/>
+          </a:prstGeom>
+        </p:spPr>
+      </p:pic>
+      <p:sp>
+        <p:nvSpPr>
+          <p:cNvPr id="28" name="Text 19"/>
+          <p:cNvSpPr txBox="1"/>
+          <p:nvPr/>
+        </p:nvSpPr>
+        <p:spPr>
+          <a:xfrm>
+            <a:off x="649224" y="4050792"/>
+            <a:ext cx="4608576" cy="384048"/>
+          </a:xfrm>
+          <a:prstGeom prst="rect">
+            <a:avLst/>
+          </a:prstGeom>
+          <a:noFill/>
+          <a:ln/>
+        </p:spPr>
+        <p:txBody>
+          <a:bodyPr wrap="square" lIns="0" tIns="0" rIns="0" bIns="0" rtlCol="0" anchor="ctr"/>
+          <a:lstStyle/>
+          <a:p>
+            <a:pPr rtl="1" algn="r" indent="0" marL="0">
+              <a:buNone/>
+            </a:pPr>
+            <a:r>
+              <a:rPr lang="en-US" sz="1500" b="1" dirty="0">
+                <a:solidFill>
+                  <a:srgbClr val="2D6A66"/>
+                </a:solidFill>
+              </a:rPr>
+              <a:t>رصيد المديونية حسب التبويب</a:t>
+            </a:r>
+            <a:endParaRPr lang="en-US" sz="1500" dirty="0"/>
+          </a:p>
+        </p:txBody>
+      </p:sp>
+      <p:graphicFrame>
+        <p:nvGraphicFramePr>
+          <p:cNvPr id="29" name="Chart 3" descr=""/>
+          <p:cNvGraphicFramePr/>
+          <p:nvPr/>
+        </p:nvGraphicFramePr>
+        <p:xfrm>
+          <a:off x="640080" y="4507992"/>
+          <a:ext cx="5157216" cy="1984248"/>
+        </p:xfrm>
+        <a:graphic xmlns:a="http://schemas.openxmlformats.org/drawingml/2006/main">
+          <a:graphicData uri="http://schemas.openxmlformats.org/drawingml/2006/chart">
+            <c:chart xmlns:c="http://schemas.openxmlformats.org/drawingml/2006/chart" r:id="rId8"/>
           </a:graphicData>
         </a:graphic>
       </p:graphicFrame>

</xml_diff>